<commit_message>
docs(presentation): add connectors/services and potential slides
Add a slide on candidate connector families (mobile money, UPI, PIX,
European bank, international PSP) grounded in CDC ch.5 — explicit that
these are candidates, not acquired integrations, and that the personal
baseline stays usable without them. Add a closing "Potentiel" slide with
the post-hackathon roadmap and business model from CDC ch.26/5.

Co-Authored-By: Claude Sonnet 5 <noreply@anthropic.com>
Claude-Session: https://claude.ai/code/session_01GVjnCnga6LrWgo7YT1mivM
</commit_message>
<xml_diff>
--- a/docs/presentation/octro-presentation.pptx
+++ b/docs/presentation/octro-presentation.pptx
@@ -13,6 +13,8 @@
     <p:sldId id="261" r:id="rId12"/>
     <p:sldId id="262" r:id="rId13"/>
     <p:sldId id="263" r:id="rId14"/>
+    <p:sldId id="264" r:id="rId15"/>
+    <p:sldId id="265" r:id="rId16"/>
   </p:sldIdLst>
   <p:sldSz cx="12191695" cy="6858000" type="screen4x3"/>
   <p:notesSz cx="6858000" cy="9144000"/>
@@ -3249,6 +3251,365 @@
 </p:sld>
 </file>
 
+<file path=ppt/slides/slide10.xml><?xml version="1.0" encoding="utf-8"?>
+<p:sld xmlns:a="http://schemas.openxmlformats.org/drawingml/2006/main" xmlns:p="http://schemas.openxmlformats.org/presentationml/2006/main" xmlns:r="http://schemas.openxmlformats.org/officeDocument/2006/relationships">
+  <p:cSld>
+    <p:spTree>
+      <p:nvGrpSpPr>
+        <p:cNvPr id="1" name=""/>
+        <p:cNvGrpSpPr/>
+        <p:nvPr/>
+      </p:nvGrpSpPr>
+      <p:grpSpPr/>
+      <p:sp>
+        <p:nvSpPr>
+          <p:cNvPr id="2" name="Rectangle 1"/>
+          <p:cNvSpPr/>
+          <p:nvPr/>
+        </p:nvSpPr>
+        <p:spPr>
+          <a:xfrm>
+            <a:off x="0" y="0"/>
+            <a:ext cx="12191695" cy="6858000"/>
+          </a:xfrm>
+          <a:prstGeom prst="rect">
+            <a:avLst/>
+          </a:prstGeom>
+          <a:solidFill>
+            <a:srgbClr val="F5F2E8"/>
+          </a:solidFill>
+          <a:ln>
+            <a:noFill/>
+          </a:ln>
+          <a:effectLst/>
+        </p:spPr>
+        <p:style>
+          <a:lnRef idx="1">
+            <a:schemeClr val="accent1"/>
+          </a:lnRef>
+          <a:fillRef idx="3">
+            <a:schemeClr val="accent1"/>
+          </a:fillRef>
+          <a:effectRef idx="2">
+            <a:schemeClr val="accent1"/>
+          </a:effectRef>
+          <a:fontRef idx="minor">
+            <a:schemeClr val="lt1"/>
+          </a:fontRef>
+        </p:style>
+        <p:txBody>
+          <a:bodyPr rtlCol="0" anchor="ctr"/>
+          <a:lstStyle/>
+          <a:p>
+            <a:pPr algn="ctr"/>
+          </a:p>
+        </p:txBody>
+      </p:sp>
+      <p:sp>
+        <p:nvSpPr>
+          <p:cNvPr id="3" name="TextBox 2"/>
+          <p:cNvSpPr txBox="1"/>
+          <p:nvPr/>
+        </p:nvSpPr>
+        <p:spPr>
+          <a:xfrm>
+            <a:off x="658368" y="228600"/>
+            <a:ext cx="7315200" cy="365760"/>
+          </a:xfrm>
+          <a:prstGeom prst="rect">
+            <a:avLst/>
+          </a:prstGeom>
+          <a:noFill/>
+        </p:spPr>
+        <p:txBody>
+          <a:bodyPr wrap="none">
+            <a:spAutoFit/>
+          </a:bodyPr>
+          <a:lstStyle/>
+          <a:p>
+            <a:r>
+              <a:rPr sz="1300" b="1">
+                <a:solidFill>
+                  <a:srgbClr val="304B35"/>
+                </a:solidFill>
+                <a:latin typeface="Arial"/>
+              </a:rPr>
+              <a:t>POTENTIEL</a:t>
+            </a:r>
+          </a:p>
+        </p:txBody>
+      </p:sp>
+      <p:sp>
+        <p:nvSpPr>
+          <p:cNvPr id="4" name="TextBox 3"/>
+          <p:cNvSpPr txBox="1"/>
+          <p:nvPr/>
+        </p:nvSpPr>
+        <p:spPr>
+          <a:xfrm>
+            <a:off x="640080" y="502920"/>
+            <a:ext cx="10881360" cy="914400"/>
+          </a:xfrm>
+          <a:prstGeom prst="rect">
+            <a:avLst/>
+          </a:prstGeom>
+          <a:noFill/>
+        </p:spPr>
+        <p:txBody>
+          <a:bodyPr wrap="square">
+            <a:spAutoFit/>
+          </a:bodyPr>
+          <a:lstStyle/>
+          <a:p>
+            <a:r>
+              <a:rPr sz="3400" b="1">
+                <a:solidFill>
+                  <a:srgbClr val="20271F"/>
+                </a:solidFill>
+                <a:latin typeface="Georgia"/>
+              </a:rPr>
+              <a:t>Un chemin par capacité, pas une promesse</a:t>
+            </a:r>
+          </a:p>
+        </p:txBody>
+      </p:sp>
+      <p:sp>
+        <p:nvSpPr>
+          <p:cNvPr id="5" name="Rectangle 4"/>
+          <p:cNvSpPr/>
+          <p:nvPr/>
+        </p:nvSpPr>
+        <p:spPr>
+          <a:xfrm>
+            <a:off x="640080" y="1417320"/>
+            <a:ext cx="1280160" cy="50800"/>
+          </a:xfrm>
+          <a:prstGeom prst="rect">
+            <a:avLst/>
+          </a:prstGeom>
+          <a:solidFill>
+            <a:srgbClr val="304B35"/>
+          </a:solidFill>
+          <a:ln>
+            <a:noFill/>
+          </a:ln>
+          <a:effectLst/>
+        </p:spPr>
+        <p:style>
+          <a:lnRef idx="1">
+            <a:schemeClr val="accent1"/>
+          </a:lnRef>
+          <a:fillRef idx="3">
+            <a:schemeClr val="accent1"/>
+          </a:fillRef>
+          <a:effectRef idx="2">
+            <a:schemeClr val="accent1"/>
+          </a:effectRef>
+          <a:fontRef idx="minor">
+            <a:schemeClr val="lt1"/>
+          </a:fontRef>
+        </p:style>
+        <p:txBody>
+          <a:bodyPr rtlCol="0" anchor="ctr"/>
+          <a:lstStyle/>
+          <a:p>
+            <a:pPr algn="ctr"/>
+          </a:p>
+        </p:txBody>
+      </p:sp>
+      <p:sp>
+        <p:nvSpPr>
+          <p:cNvPr id="6" name="TextBox 5"/>
+          <p:cNvSpPr txBox="1"/>
+          <p:nvPr/>
+        </p:nvSpPr>
+        <p:spPr>
+          <a:xfrm>
+            <a:off x="640080" y="6446520"/>
+            <a:ext cx="10881360" cy="320040"/>
+          </a:xfrm>
+          <a:prstGeom prst="rect">
+            <a:avLst/>
+          </a:prstGeom>
+          <a:noFill/>
+        </p:spPr>
+        <p:txBody>
+          <a:bodyPr wrap="none">
+            <a:spAutoFit/>
+          </a:bodyPr>
+          <a:lstStyle/>
+          <a:p>
+            <a:r>
+              <a:rPr sz="1100">
+                <a:solidFill>
+                  <a:srgbClr val="6B7463"/>
+                </a:solidFill>
+                <a:latin typeface="Arial"/>
+              </a:rPr>
+              <a:t>Octro v2.2 — Track 1 Loaded</a:t>
+            </a:r>
+          </a:p>
+        </p:txBody>
+      </p:sp>
+      <p:sp>
+        <p:nvSpPr>
+          <p:cNvPr id="7" name="TextBox 6"/>
+          <p:cNvSpPr txBox="1"/>
+          <p:nvPr/>
+        </p:nvSpPr>
+        <p:spPr>
+          <a:xfrm>
+            <a:off x="685800" y="1920240"/>
+            <a:ext cx="10789920" cy="4389120"/>
+          </a:xfrm>
+          <a:prstGeom prst="rect">
+            <a:avLst/>
+          </a:prstGeom>
+          <a:noFill/>
+        </p:spPr>
+        <p:txBody>
+          <a:bodyPr wrap="square">
+            <a:spAutoFit/>
+          </a:bodyPr>
+          <a:lstStyle/>
+          <a:p>
+            <a:pPr>
+              <a:spcAft>
+                <a:spcPts val="1000"/>
+              </a:spcAft>
+            </a:pPr>
+            <a:r>
+              <a:rPr sz="1900" b="1">
+                <a:solidFill>
+                  <a:srgbClr val="20271F"/>
+                </a:solidFill>
+                <a:latin typeface="Arial"/>
+              </a:rPr>
+              <a:t>▸ Semaines 1-2 : stabiliser les adaptateurs, tester l'utilité avec particuliers et indépendants</a:t>
+            </a:r>
+          </a:p>
+          <a:p>
+            <a:pPr>
+              <a:spcAft>
+                <a:spcPts val="1000"/>
+              </a:spcAft>
+            </a:pPr>
+            <a:r>
+              <a:rPr sz="1900" b="1">
+                <a:solidFill>
+                  <a:srgbClr val="20271F"/>
+                </a:solidFill>
+                <a:latin typeface="Arial"/>
+              </a:rPr>
+              <a:t>▸ Semaines 3-6 : connecteurs autorisés, backtests, instrumentation du risque</a:t>
+            </a:r>
+          </a:p>
+          <a:p>
+            <a:pPr>
+              <a:spcAft>
+                <a:spcPts val="1000"/>
+              </a:spcAft>
+            </a:pPr>
+            <a:r>
+              <a:rPr sz="1900" b="1">
+                <a:solidFill>
+                  <a:srgbClr val="20271F"/>
+                </a:solidFill>
+                <a:latin typeface="Arial"/>
+              </a:rPr>
+              <a:t>▸ Semaines 7-12 : pilote par capacité et juridiction validées</a:t>
+            </a:r>
+          </a:p>
+          <a:p>
+            <a:pPr>
+              <a:spcAft>
+                <a:spcPts val="1000"/>
+              </a:spcAft>
+            </a:pPr>
+            <a:r>
+              <a:rPr sz="1900" b="1">
+                <a:solidFill>
+                  <a:srgbClr val="20271F"/>
+                </a:solidFill>
+                <a:latin typeface="Arial"/>
+              </a:rPr>
+              <a:t>▸ Modèle économique proposé</a:t>
+            </a:r>
+          </a:p>
+          <a:p>
+            <a:pPr lvl="1">
+              <a:spcAft>
+                <a:spcPts val="400"/>
+              </a:spcAft>
+            </a:pPr>
+            <a:r>
+              <a:rPr sz="1600" b="0">
+                <a:solidFill>
+                  <a:srgbClr val="304B35"/>
+                </a:solidFill>
+                <a:latin typeface="Arial"/>
+              </a:rPr>
+              <a:t>–  Socle personnel gratuit (saisie, calendrier, simulation) ; abonnement facultatif pour automatisations avancées ; offre équipe/API</a:t>
+            </a:r>
+          </a:p>
+          <a:p>
+            <a:pPr>
+              <a:spcAft>
+                <a:spcPts val="1000"/>
+              </a:spcAft>
+            </a:pPr>
+            <a:r>
+              <a:rPr sz="1900" b="1">
+                <a:solidFill>
+                  <a:srgbClr val="20271F"/>
+                </a:solidFill>
+                <a:latin typeface="Arial"/>
+              </a:rPr>
+              <a:t>▸ Machine learning post-hackathon</a:t>
+            </a:r>
+          </a:p>
+          <a:p>
+            <a:pPr lvl="1">
+              <a:spcAft>
+                <a:spcPts val="400"/>
+              </a:spcAft>
+            </a:pPr>
+            <a:r>
+              <a:rPr sz="1600" b="0">
+                <a:solidFill>
+                  <a:srgbClr val="304B35"/>
+                </a:solidFill>
+                <a:latin typeface="Arial"/>
+              </a:rPr>
+              <a:t>–  Estimation des délais et défauts par historique autorisé, séparation entraînement/validation, comparée à une baseline calendrier avant d'être retenue</a:t>
+            </a:r>
+          </a:p>
+          <a:p>
+            <a:pPr>
+              <a:spcAft>
+                <a:spcPts val="1000"/>
+              </a:spcAft>
+            </a:pPr>
+            <a:r>
+              <a:rPr sz="1900" b="1">
+                <a:solidFill>
+                  <a:srgbClr val="20271F"/>
+                </a:solidFill>
+                <a:latin typeface="Arial"/>
+              </a:rPr>
+              <a:t>▸ Sponsoring, DID et connecteurs avancent selon les résultats de recette, jamais selon une promesse de disponibilité mondiale</a:t>
+            </a:r>
+          </a:p>
+        </p:txBody>
+      </p:sp>
+    </p:spTree>
+  </p:cSld>
+  <p:clrMapOvr>
+    <a:masterClrMapping/>
+  </p:clrMapOvr>
+</p:sld>
+</file>
+
 <file path=ppt/slides/slide2.xml><?xml version="1.0" encoding="utf-8"?>
 <p:sld xmlns:a="http://schemas.openxmlformats.org/drawingml/2006/main" xmlns:p="http://schemas.openxmlformats.org/presentationml/2006/main" xmlns:r="http://schemas.openxmlformats.org/officeDocument/2006/relationships">
   <p:cSld>
@@ -3944,7 +4305,7 @@
             <a:avLst/>
           </a:prstGeom>
           <a:solidFill>
-            <a:srgbClr val="20271F"/>
+            <a:srgbClr val="F5F2E8"/>
           </a:solidFill>
           <a:ln>
             <a:noFill/>
@@ -3981,8 +4342,8 @@
         </p:nvSpPr>
         <p:spPr>
           <a:xfrm>
-            <a:off x="822960" y="2743200"/>
-            <a:ext cx="10515600" cy="1463040"/>
+            <a:off x="658368" y="228600"/>
+            <a:ext cx="7315200" cy="365760"/>
           </a:xfrm>
           <a:prstGeom prst="rect">
             <a:avLst/>
@@ -3996,13 +4357,13 @@
           <a:lstStyle/>
           <a:p>
             <a:r>
-              <a:rPr sz="4400" b="1">
-                <a:solidFill>
-                  <a:srgbClr val="F5F2E8"/>
-                </a:solidFill>
-                <a:latin typeface="Georgia"/>
-              </a:rPr>
-              <a:t>Retour développeur — points clés</a:t>
+              <a:rPr sz="1300" b="1">
+                <a:solidFill>
+                  <a:srgbClr val="304B35"/>
+                </a:solidFill>
+                <a:latin typeface="Arial"/>
+              </a:rPr>
+              <a:t>OÙ OCTRO PEUT S'INTÉGRER</a:t>
             </a:r>
           </a:p>
         </p:txBody>
@@ -4015,8 +4376,8 @@
         </p:nvSpPr>
         <p:spPr>
           <a:xfrm>
-            <a:off x="868680" y="3794760"/>
-            <a:ext cx="10058400" cy="548640"/>
+            <a:off x="640080" y="502920"/>
+            <a:ext cx="10881360" cy="914400"/>
           </a:xfrm>
           <a:prstGeom prst="rect">
             <a:avLst/>
@@ -4024,19 +4385,216 @@
           <a:noFill/>
         </p:spPr>
         <p:txBody>
+          <a:bodyPr wrap="square">
+            <a:spAutoFit/>
+          </a:bodyPr>
+          <a:lstStyle/>
+          <a:p>
+            <a:r>
+              <a:rPr sz="3400" b="1">
+                <a:solidFill>
+                  <a:srgbClr val="20271F"/>
+                </a:solidFill>
+                <a:latin typeface="Georgia"/>
+              </a:rPr>
+              <a:t>Des connecteurs candidats, pas acquis</a:t>
+            </a:r>
+          </a:p>
+        </p:txBody>
+      </p:sp>
+      <p:sp>
+        <p:nvSpPr>
+          <p:cNvPr id="5" name="Rectangle 4"/>
+          <p:cNvSpPr/>
+          <p:nvPr/>
+        </p:nvSpPr>
+        <p:spPr>
+          <a:xfrm>
+            <a:off x="640080" y="1417320"/>
+            <a:ext cx="1280160" cy="50800"/>
+          </a:xfrm>
+          <a:prstGeom prst="rect">
+            <a:avLst/>
+          </a:prstGeom>
+          <a:solidFill>
+            <a:srgbClr val="304B35"/>
+          </a:solidFill>
+          <a:ln>
+            <a:noFill/>
+          </a:ln>
+          <a:effectLst/>
+        </p:spPr>
+        <p:style>
+          <a:lnRef idx="1">
+            <a:schemeClr val="accent1"/>
+          </a:lnRef>
+          <a:fillRef idx="3">
+            <a:schemeClr val="accent1"/>
+          </a:fillRef>
+          <a:effectRef idx="2">
+            <a:schemeClr val="accent1"/>
+          </a:effectRef>
+          <a:fontRef idx="minor">
+            <a:schemeClr val="lt1"/>
+          </a:fontRef>
+        </p:style>
+        <p:txBody>
+          <a:bodyPr rtlCol="0" anchor="ctr"/>
+          <a:lstStyle/>
+          <a:p>
+            <a:pPr algn="ctr"/>
+          </a:p>
+        </p:txBody>
+      </p:sp>
+      <p:sp>
+        <p:nvSpPr>
+          <p:cNvPr id="6" name="TextBox 5"/>
+          <p:cNvSpPr txBox="1"/>
+          <p:nvPr/>
+        </p:nvSpPr>
+        <p:spPr>
+          <a:xfrm>
+            <a:off x="640080" y="6446520"/>
+            <a:ext cx="10881360" cy="320040"/>
+          </a:xfrm>
+          <a:prstGeom prst="rect">
+            <a:avLst/>
+          </a:prstGeom>
+          <a:noFill/>
+        </p:spPr>
+        <p:txBody>
           <a:bodyPr wrap="none">
             <a:spAutoFit/>
           </a:bodyPr>
           <a:lstStyle/>
           <a:p>
             <a:r>
-              <a:rPr sz="1800">
-                <a:solidFill>
-                  <a:srgbClr val="B8C98A"/>
-                </a:solidFill>
-                <a:latin typeface="Arial"/>
-              </a:rPr>
-              <a:t>Algorithmes  ·  Orchestration agentique  ·  MCP  ·  Machine learning</a:t>
+              <a:rPr sz="1100">
+                <a:solidFill>
+                  <a:srgbClr val="6B7463"/>
+                </a:solidFill>
+                <a:latin typeface="Arial"/>
+              </a:rPr>
+              <a:t>Octro v2.2 — Track 1 Loaded</a:t>
+            </a:r>
+          </a:p>
+        </p:txBody>
+      </p:sp>
+      <p:sp>
+        <p:nvSpPr>
+          <p:cNvPr id="7" name="TextBox 6"/>
+          <p:cNvSpPr txBox="1"/>
+          <p:nvPr/>
+        </p:nvSpPr>
+        <p:spPr>
+          <a:xfrm>
+            <a:off x="685800" y="1920240"/>
+            <a:ext cx="10789920" cy="4389120"/>
+          </a:xfrm>
+          <a:prstGeom prst="rect">
+            <a:avLst/>
+          </a:prstGeom>
+          <a:noFill/>
+        </p:spPr>
+        <p:txBody>
+          <a:bodyPr wrap="square">
+            <a:spAutoFit/>
+          </a:bodyPr>
+          <a:lstStyle/>
+          <a:p>
+            <a:pPr>
+              <a:spcAft>
+                <a:spcPts val="1000"/>
+              </a:spcAft>
+            </a:pPr>
+            <a:r>
+              <a:rPr sz="2000" b="1">
+                <a:solidFill>
+                  <a:srgbClr val="20271F"/>
+                </a:solidFill>
+                <a:latin typeface="Arial"/>
+              </a:rPr>
+              <a:t>▸ Mobile money (pays africains), UPI (Inde), PIX (Brésil), banque européenne, PSP international</a:t>
+            </a:r>
+          </a:p>
+          <a:p>
+            <a:pPr lvl="1">
+              <a:spcAft>
+                <a:spcPts val="400"/>
+              </a:spcAft>
+            </a:pPr>
+            <a:r>
+              <a:rPr sz="1600" b="0">
+                <a:solidFill>
+                  <a:srgbClr val="304B35"/>
+                </a:solidFill>
+                <a:latin typeface="Arial"/>
+              </a:rPr>
+              <a:t>–  Familles de connecteurs candidates ; langue, faible débit, formats et capacités locales traités indépendamment</a:t>
+            </a:r>
+          </a:p>
+          <a:p>
+            <a:pPr>
+              <a:spcAft>
+                <a:spcPts val="1000"/>
+              </a:spcAft>
+            </a:pPr>
+            <a:r>
+              <a:rPr sz="2000" b="1">
+                <a:solidFill>
+                  <a:srgbClr val="20271F"/>
+                </a:solidFill>
+                <a:latin typeface="Arial"/>
+              </a:rPr>
+              <a:t>▸ Sans connecteur local : saisie manuelle et import restent toujours possibles</a:t>
+            </a:r>
+          </a:p>
+          <a:p>
+            <a:pPr lvl="1">
+              <a:spcAft>
+                <a:spcPts val="400"/>
+              </a:spcAft>
+            </a:pPr>
+            <a:r>
+              <a:rPr sz="1600" b="0">
+                <a:solidFill>
+                  <a:srgbClr val="304B35"/>
+                </a:solidFill>
+                <a:latin typeface="Arial"/>
+              </a:rPr>
+              <a:t>–  Le socle personnel reste utile même quand le financement ou la connexion sont indisponibles</a:t>
+            </a:r>
+          </a:p>
+          <a:p>
+            <a:pPr>
+              <a:spcAft>
+                <a:spcPts val="1000"/>
+              </a:spcAft>
+            </a:pPr>
+            <a:r>
+              <a:rPr sz="2000" b="1">
+                <a:solidFill>
+                  <a:srgbClr val="20271F"/>
+                </a:solidFill>
+                <a:latin typeface="Arial"/>
+              </a:rPr>
+              <a:t>▸ Disponibilité évaluée par capacité et par juridiction, jamais globale par défaut</a:t>
+            </a:r>
+          </a:p>
+          <a:p>
+            <a:pPr lvl="1">
+              <a:spcAft>
+                <a:spcPts val="400"/>
+              </a:spcAft>
+            </a:pPr>
+            <a:r>
+              <a:rPr sz="1600" b="0">
+                <a:solidFill>
+                  <a:srgbClr val="304B35"/>
+                </a:solidFill>
+                <a:latin typeface="Arial"/>
+              </a:rPr>
+              <a:t>–  Matrice séparée pour analyse / connexion / transfert / financement — « mondial » ne veut pas dire que tous les rails fonctionnent partout</a:t>
             </a:r>
           </a:p>
         </p:txBody>
@@ -4074,7 +4632,7 @@
             <a:avLst/>
           </a:prstGeom>
           <a:solidFill>
-            <a:srgbClr val="F5F2E8"/>
+            <a:srgbClr val="20271F"/>
           </a:solidFill>
           <a:ln>
             <a:noFill/>
@@ -4111,8 +4669,8 @@
         </p:nvSpPr>
         <p:spPr>
           <a:xfrm>
-            <a:off x="658368" y="228600"/>
-            <a:ext cx="7315200" cy="365760"/>
+            <a:off x="822960" y="2743200"/>
+            <a:ext cx="10515600" cy="1463040"/>
           </a:xfrm>
           <a:prstGeom prst="rect">
             <a:avLst/>
@@ -4126,13 +4684,13 @@
           <a:lstStyle/>
           <a:p>
             <a:r>
-              <a:rPr sz="1300" b="1">
-                <a:solidFill>
-                  <a:srgbClr val="304B35"/>
-                </a:solidFill>
-                <a:latin typeface="Arial"/>
-              </a:rPr>
-              <a:t>RETOUR DÉVELOPPEUR</a:t>
+              <a:rPr sz="4400" b="1">
+                <a:solidFill>
+                  <a:srgbClr val="F5F2E8"/>
+                </a:solidFill>
+                <a:latin typeface="Georgia"/>
+              </a:rPr>
+              <a:t>Retour développeur — points clés</a:t>
             </a:r>
           </a:p>
         </p:txBody>
@@ -4145,8 +4703,8 @@
         </p:nvSpPr>
         <p:spPr>
           <a:xfrm>
-            <a:off x="640080" y="502920"/>
-            <a:ext cx="10881360" cy="914400"/>
+            <a:off x="868680" y="3794760"/>
+            <a:ext cx="10058400" cy="548640"/>
           </a:xfrm>
           <a:prstGeom prst="rect">
             <a:avLst/>
@@ -4154,248 +4712,19 @@
           <a:noFill/>
         </p:spPr>
         <p:txBody>
-          <a:bodyPr wrap="square">
-            <a:spAutoFit/>
-          </a:bodyPr>
-          <a:lstStyle/>
-          <a:p>
-            <a:r>
-              <a:rPr sz="3400" b="1">
-                <a:solidFill>
-                  <a:srgbClr val="20271F"/>
-                </a:solidFill>
-                <a:latin typeface="Georgia"/>
-              </a:rPr>
-              <a:t>Algorithmes utilisés</a:t>
-            </a:r>
-          </a:p>
-        </p:txBody>
-      </p:sp>
-      <p:sp>
-        <p:nvSpPr>
-          <p:cNvPr id="5" name="Rectangle 4"/>
-          <p:cNvSpPr/>
-          <p:nvPr/>
-        </p:nvSpPr>
-        <p:spPr>
-          <a:xfrm>
-            <a:off x="640080" y="1417320"/>
-            <a:ext cx="1280160" cy="50800"/>
-          </a:xfrm>
-          <a:prstGeom prst="rect">
-            <a:avLst/>
-          </a:prstGeom>
-          <a:solidFill>
-            <a:srgbClr val="304B35"/>
-          </a:solidFill>
-          <a:ln>
-            <a:noFill/>
-          </a:ln>
-          <a:effectLst/>
-        </p:spPr>
-        <p:style>
-          <a:lnRef idx="1">
-            <a:schemeClr val="accent1"/>
-          </a:lnRef>
-          <a:fillRef idx="3">
-            <a:schemeClr val="accent1"/>
-          </a:fillRef>
-          <a:effectRef idx="2">
-            <a:schemeClr val="accent1"/>
-          </a:effectRef>
-          <a:fontRef idx="minor">
-            <a:schemeClr val="lt1"/>
-          </a:fontRef>
-        </p:style>
-        <p:txBody>
-          <a:bodyPr rtlCol="0" anchor="ctr"/>
-          <a:lstStyle/>
-          <a:p>
-            <a:pPr algn="ctr"/>
-          </a:p>
-        </p:txBody>
-      </p:sp>
-      <p:sp>
-        <p:nvSpPr>
-          <p:cNvPr id="6" name="TextBox 5"/>
-          <p:cNvSpPr txBox="1"/>
-          <p:nvPr/>
-        </p:nvSpPr>
-        <p:spPr>
-          <a:xfrm>
-            <a:off x="640080" y="6446520"/>
-            <a:ext cx="10881360" cy="320040"/>
-          </a:xfrm>
-          <a:prstGeom prst="rect">
-            <a:avLst/>
-          </a:prstGeom>
-          <a:noFill/>
-        </p:spPr>
-        <p:txBody>
           <a:bodyPr wrap="none">
             <a:spAutoFit/>
           </a:bodyPr>
           <a:lstStyle/>
           <a:p>
             <a:r>
-              <a:rPr sz="1100">
-                <a:solidFill>
-                  <a:srgbClr val="6B7463"/>
-                </a:solidFill>
-                <a:latin typeface="Arial"/>
-              </a:rPr>
-              <a:t>Octro v2.2 — Track 1 Loaded</a:t>
-            </a:r>
-          </a:p>
-        </p:txBody>
-      </p:sp>
-      <p:sp>
-        <p:nvSpPr>
-          <p:cNvPr id="7" name="TextBox 6"/>
-          <p:cNvSpPr txBox="1"/>
-          <p:nvPr/>
-        </p:nvSpPr>
-        <p:spPr>
-          <a:xfrm>
-            <a:off x="685800" y="1920240"/>
-            <a:ext cx="10789920" cy="4389120"/>
-          </a:xfrm>
-          <a:prstGeom prst="rect">
-            <a:avLst/>
-          </a:prstGeom>
-          <a:noFill/>
-        </p:spPr>
-        <p:txBody>
-          <a:bodyPr wrap="square">
-            <a:spAutoFit/>
-          </a:bodyPr>
-          <a:lstStyle/>
-          <a:p>
-            <a:pPr>
-              <a:spcAft>
-                <a:spcPts val="1000"/>
-              </a:spcAft>
-            </a:pPr>
-            <a:r>
-              <a:rPr sz="2000" b="1">
-                <a:solidFill>
-                  <a:srgbClr val="20271F"/>
-                </a:solidFill>
-                <a:latin typeface="Arial"/>
-              </a:rPr>
-              <a:t>▸ CVaR — forme fermée de Rockafellar–Uryasev</a:t>
-            </a:r>
-          </a:p>
-          <a:p>
-            <a:pPr lvl="1">
-              <a:spcAft>
-                <a:spcPts val="400"/>
-              </a:spcAft>
-            </a:pPr>
-            <a:r>
-              <a:rPr sz="1600" b="0">
-                <a:solidFill>
-                  <a:srgbClr val="304B35"/>
-                </a:solidFill>
-                <a:latin typeface="Arial"/>
-              </a:rPr>
-              <a:t>–  Vérifié sur la fixture CDC : pertes [0,0,100], poids [0,80 ; 0,15 ; 0,05] → CVaR95 = 100</a:t>
-            </a:r>
-          </a:p>
-          <a:p>
-            <a:pPr>
-              <a:spcAft>
-                <a:spcPts val="1000"/>
-              </a:spcAft>
-            </a:pPr>
-            <a:r>
-              <a:rPr sz="2000" b="1">
-                <a:solidFill>
-                  <a:srgbClr val="20271F"/>
-                </a:solidFill>
-                <a:latin typeface="Arial"/>
-              </a:rPr>
-              <a:t>▸ Moteur personnel sans dette</a:t>
-            </a:r>
-          </a:p>
-          <a:p>
-            <a:pPr lvl="1">
-              <a:spcAft>
-                <a:spcPts val="400"/>
-              </a:spcAft>
-            </a:pPr>
-            <a:r>
-              <a:rPr sz="1600" b="0">
-                <a:solidFill>
-                  <a:srgbClr val="304B35"/>
-                </a:solidFill>
-                <a:latin typeface="Arial"/>
-              </a:rPr>
-              <a:t>–  Réserve protégée en contrainte dure, jamais relâchée automatiquement ; montant revérifié après arrondi</a:t>
-            </a:r>
-          </a:p>
-          <a:p>
-            <a:pPr>
-              <a:spcAft>
-                <a:spcPts val="1000"/>
-              </a:spcAft>
-            </a:pPr>
-            <a:r>
-              <a:rPr sz="2000" b="1">
-                <a:solidFill>
-                  <a:srgbClr val="20271F"/>
-                </a:solidFill>
-                <a:latin typeface="Arial"/>
-              </a:rPr>
-              <a:t>▸ Allocation de financement</a:t>
-            </a:r>
-          </a:p>
-          <a:p>
-            <a:pPr lvl="1">
-              <a:spcAft>
-                <a:spcPts val="400"/>
-              </a:spcAft>
-            </a:pPr>
-            <a:r>
-              <a:rPr sz="1600" b="0">
-                <a:solidFill>
-                  <a:srgbClr val="304B35"/>
-                </a:solidFill>
-                <a:latin typeface="Arial"/>
-              </a:rPr>
-              <a:t>–  Offre la moins chère d'abord (glouton), dette terminale conservée au-delà de l'horizon</a:t>
-            </a:r>
-          </a:p>
-          <a:p>
-            <a:pPr>
-              <a:spcAft>
-                <a:spcPts val="1000"/>
-              </a:spcAft>
-            </a:pPr>
-            <a:r>
-              <a:rPr sz="2000" b="1">
-                <a:solidFill>
-                  <a:srgbClr val="20271F"/>
-                </a:solidFill>
-                <a:latin typeface="Arial"/>
-              </a:rPr>
-              <a:t>▸ Pas encore de solveur LP/MILP unifié (scipy/HiGHS)</a:t>
-            </a:r>
-          </a:p>
-          <a:p>
-            <a:pPr lvl="1">
-              <a:spcAft>
-                <a:spcPts val="400"/>
-              </a:spcAft>
-            </a:pPr>
-            <a:r>
-              <a:rPr sz="1600" b="0">
-                <a:solidFill>
-                  <a:srgbClr val="304B35"/>
-                </a:solidFill>
-                <a:latin typeface="Arial"/>
-              </a:rPr>
-              <a:t>–  Chaque garantie du CDC est prouvée sur les scénarios de démo, pas sur un plan combiné multi-actifs</a:t>
+              <a:rPr sz="1800">
+                <a:solidFill>
+                  <a:srgbClr val="B8C98A"/>
+                </a:solidFill>
+                <a:latin typeface="Arial"/>
+              </a:rPr>
+              <a:t>Algorithmes  ·  Orchestration agentique  ·  MCP  ·  Machine learning</a:t>
             </a:r>
           </a:p>
         </p:txBody>
@@ -4525,7 +4854,7 @@
                 </a:solidFill>
                 <a:latin typeface="Georgia"/>
               </a:rPr>
-              <a:t>Orchestration agentique</a:t>
+              <a:t>Algorithmes utilisés</a:t>
             </a:r>
           </a:p>
         </p:txBody>
@@ -4642,7 +4971,23 @@
                 </a:solidFill>
                 <a:latin typeface="Arial"/>
               </a:rPr>
-              <a:t>▸ Coordinateur borné : maximum 12 appels d'outils (AGT-01)</a:t>
+              <a:t>▸ CVaR — forme fermée de Rockafellar–Uryasev</a:t>
+            </a:r>
+          </a:p>
+          <a:p>
+            <a:pPr lvl="1">
+              <a:spcAft>
+                <a:spcPts val="400"/>
+              </a:spcAft>
+            </a:pPr>
+            <a:r>
+              <a:rPr sz="1600" b="0">
+                <a:solidFill>
+                  <a:srgbClr val="304B35"/>
+                </a:solidFill>
+                <a:latin typeface="Arial"/>
+              </a:rPr>
+              <a:t>–  Vérifié sur la fixture CDC : pertes [0,0,100], poids [0,80 ; 0,15 ; 0,05] → CVaR95 = 100</a:t>
             </a:r>
           </a:p>
           <a:p>
@@ -4658,7 +5003,23 @@
                 </a:solidFill>
                 <a:latin typeface="Arial"/>
               </a:rPr>
-              <a:t>▸ Aucun outil de signature ou de soumission accessible au LLM (AGT-02)</a:t>
+              <a:t>▸ Moteur personnel sans dette</a:t>
+            </a:r>
+          </a:p>
+          <a:p>
+            <a:pPr lvl="1">
+              <a:spcAft>
+                <a:spcPts val="400"/>
+              </a:spcAft>
+            </a:pPr>
+            <a:r>
+              <a:rPr sz="1600" b="0">
+                <a:solidFill>
+                  <a:srgbClr val="304B35"/>
+                </a:solidFill>
+                <a:latin typeface="Arial"/>
+              </a:rPr>
+              <a:t>–  Réserve protégée en contrainte dure, jamais relâchée automatiquement ; montant revérifié après arrondi</a:t>
             </a:r>
           </a:p>
           <a:p>
@@ -4674,7 +5035,23 @@
                 </a:solidFill>
                 <a:latin typeface="Arial"/>
               </a:rPr>
-              <a:t>▸ Bascule déterministe si le fournisseur LLM est indisponible (AGT-03)</a:t>
+              <a:t>▸ Allocation de financement</a:t>
+            </a:r>
+          </a:p>
+          <a:p>
+            <a:pPr lvl="1">
+              <a:spcAft>
+                <a:spcPts val="400"/>
+              </a:spcAft>
+            </a:pPr>
+            <a:r>
+              <a:rPr sz="1600" b="0">
+                <a:solidFill>
+                  <a:srgbClr val="304B35"/>
+                </a:solidFill>
+                <a:latin typeface="Arial"/>
+              </a:rPr>
+              <a:t>–  Offre la moins chère d'abord (glouton), dette terminale conservée au-delà de l'horizon</a:t>
             </a:r>
           </a:p>
           <a:p>
@@ -4690,7 +5067,7 @@
                 </a:solidFill>
                 <a:latin typeface="Arial"/>
               </a:rPr>
-              <a:t>▸ Implémentation actuelle : raccourci à 2 appels (analyse + explication)</a:t>
+              <a:t>▸ Pas encore de solveur LP/MILP unifié (scipy/HiGHS)</a:t>
             </a:r>
           </a:p>
           <a:p>
@@ -4706,7 +5083,7 @@
                 </a:solidFill>
                 <a:latin typeface="Arial"/>
               </a:rPr>
-              <a:t>–  Pas encore le graphe complet à 6 étapes du CDC : collecter → analyser → simuler → expliquer → attendre décision → suivre</a:t>
+              <a:t>–  Chaque garantie du CDC est prouvée sur les scénarios de démo, pas sur un plan combiné multi-actifs</a:t>
             </a:r>
           </a:p>
         </p:txBody>
@@ -4836,7 +5213,7 @@
                 </a:solidFill>
                 <a:latin typeface="Georgia"/>
               </a:rPr>
-              <a:t>MCP (Model Context Protocol)</a:t>
+              <a:t>Orchestration agentique</a:t>
             </a:r>
           </a:p>
         </p:txBody>
@@ -4953,7 +5330,55 @@
                 </a:solidFill>
                 <a:latin typeface="Arial"/>
               </a:rPr>
-              <a:t>▸ 3 outils exposés, strictement en lecture</a:t>
+              <a:t>▸ Coordinateur borné : maximum 12 appels d'outils (AGT-01)</a:t>
+            </a:r>
+          </a:p>
+          <a:p>
+            <a:pPr>
+              <a:spcAft>
+                <a:spcPts val="1000"/>
+              </a:spcAft>
+            </a:pPr>
+            <a:r>
+              <a:rPr sz="2000" b="1">
+                <a:solidFill>
+                  <a:srgbClr val="20271F"/>
+                </a:solidFill>
+                <a:latin typeface="Arial"/>
+              </a:rPr>
+              <a:t>▸ Aucun outil de signature ou de soumission accessible au LLM (AGT-02)</a:t>
+            </a:r>
+          </a:p>
+          <a:p>
+            <a:pPr>
+              <a:spcAft>
+                <a:spcPts val="1000"/>
+              </a:spcAft>
+            </a:pPr>
+            <a:r>
+              <a:rPr sz="2000" b="1">
+                <a:solidFill>
+                  <a:srgbClr val="20271F"/>
+                </a:solidFill>
+                <a:latin typeface="Arial"/>
+              </a:rPr>
+              <a:t>▸ Bascule déterministe si le fournisseur LLM est indisponible (AGT-03)</a:t>
+            </a:r>
+          </a:p>
+          <a:p>
+            <a:pPr>
+              <a:spcAft>
+                <a:spcPts val="1000"/>
+              </a:spcAft>
+            </a:pPr>
+            <a:r>
+              <a:rPr sz="2000" b="1">
+                <a:solidFill>
+                  <a:srgbClr val="20271F"/>
+                </a:solidFill>
+                <a:latin typeface="Arial"/>
+              </a:rPr>
+              <a:t>▸ Implémentation actuelle : raccourci à 2 appels (analyse + explication)</a:t>
             </a:r>
           </a:p>
           <a:p>
@@ -4969,87 +5394,7 @@
                 </a:solidFill>
                 <a:latin typeface="Arial"/>
               </a:rPr>
-              <a:t>–  Résumé de compte, projection de trésorerie, explication de proposition</a:t>
-            </a:r>
-          </a:p>
-          <a:p>
-            <a:pPr>
-              <a:spcAft>
-                <a:spcPts val="1000"/>
-              </a:spcAft>
-            </a:pPr>
-            <a:r>
-              <a:rPr sz="2000" b="1">
-                <a:solidFill>
-                  <a:srgbClr val="20271F"/>
-                </a:solidFill>
-                <a:latin typeface="Arial"/>
-              </a:rPr>
-              <a:t>▸ Autorisation héritée de l'API métier (tenant, scope, jeton)</a:t>
-            </a:r>
-          </a:p>
-          <a:p>
-            <a:pPr lvl="1">
-              <a:spcAft>
-                <a:spcPts val="400"/>
-              </a:spcAft>
-            </a:pPr>
-            <a:r>
-              <a:rPr sz="1600" b="0">
-                <a:solidFill>
-                  <a:srgbClr val="304B35"/>
-                </a:solidFill>
-                <a:latin typeface="Arial"/>
-              </a:rPr>
-              <a:t>–  MCP ne constitue pas un second chemin d'autorisation ni une preuve de confiance en soi</a:t>
-            </a:r>
-          </a:p>
-          <a:p>
-            <a:pPr>
-              <a:spcAft>
-                <a:spcPts val="1000"/>
-              </a:spcAft>
-            </a:pPr>
-            <a:r>
-              <a:rPr sz="2000" b="1">
-                <a:solidFill>
-                  <a:srgbClr val="20271F"/>
-                </a:solidFill>
-                <a:latin typeface="Arial"/>
-              </a:rPr>
-              <a:t>▸ Signature et soumission XRPL : toujours hors du LLM et hors MCP</a:t>
-            </a:r>
-          </a:p>
-          <a:p>
-            <a:pPr>
-              <a:spcAft>
-                <a:spcPts val="1000"/>
-              </a:spcAft>
-            </a:pPr>
-            <a:r>
-              <a:rPr sz="2000" b="1">
-                <a:solidFill>
-                  <a:srgbClr val="20271F"/>
-                </a:solidFill>
-                <a:latin typeface="Arial"/>
-              </a:rPr>
-              <a:t>▸ Limite actuelle : réponses câblées en dur sur la fixture Lina</a:t>
-            </a:r>
-          </a:p>
-          <a:p>
-            <a:pPr lvl="1">
-              <a:spcAft>
-                <a:spcPts val="400"/>
-              </a:spcAft>
-            </a:pPr>
-            <a:r>
-              <a:rPr sz="1600" b="0">
-                <a:solidFill>
-                  <a:srgbClr val="304B35"/>
-                </a:solidFill>
-                <a:latin typeface="Arial"/>
-              </a:rPr>
-              <a:t>–  Pas encore branchées aux cas d'usage réels ni aux namespaces data.*/engine.* du CDC</a:t>
+              <a:t>–  Pas encore le graphe complet à 6 étapes du CDC : collecter → analyser → simuler → expliquer → attendre décision → suivre</a:t>
             </a:r>
           </a:p>
         </p:txBody>
@@ -5063,6 +5408,349 @@
 </file>
 
 <file path=ppt/slides/slide8.xml><?xml version="1.0" encoding="utf-8"?>
+<p:sld xmlns:a="http://schemas.openxmlformats.org/drawingml/2006/main" xmlns:p="http://schemas.openxmlformats.org/presentationml/2006/main" xmlns:r="http://schemas.openxmlformats.org/officeDocument/2006/relationships">
+  <p:cSld>
+    <p:spTree>
+      <p:nvGrpSpPr>
+        <p:cNvPr id="1" name=""/>
+        <p:cNvGrpSpPr/>
+        <p:nvPr/>
+      </p:nvGrpSpPr>
+      <p:grpSpPr/>
+      <p:sp>
+        <p:nvSpPr>
+          <p:cNvPr id="2" name="Rectangle 1"/>
+          <p:cNvSpPr/>
+          <p:nvPr/>
+        </p:nvSpPr>
+        <p:spPr>
+          <a:xfrm>
+            <a:off x="0" y="0"/>
+            <a:ext cx="12191695" cy="6858000"/>
+          </a:xfrm>
+          <a:prstGeom prst="rect">
+            <a:avLst/>
+          </a:prstGeom>
+          <a:solidFill>
+            <a:srgbClr val="F5F2E8"/>
+          </a:solidFill>
+          <a:ln>
+            <a:noFill/>
+          </a:ln>
+          <a:effectLst/>
+        </p:spPr>
+        <p:style>
+          <a:lnRef idx="1">
+            <a:schemeClr val="accent1"/>
+          </a:lnRef>
+          <a:fillRef idx="3">
+            <a:schemeClr val="accent1"/>
+          </a:fillRef>
+          <a:effectRef idx="2">
+            <a:schemeClr val="accent1"/>
+          </a:effectRef>
+          <a:fontRef idx="minor">
+            <a:schemeClr val="lt1"/>
+          </a:fontRef>
+        </p:style>
+        <p:txBody>
+          <a:bodyPr rtlCol="0" anchor="ctr"/>
+          <a:lstStyle/>
+          <a:p>
+            <a:pPr algn="ctr"/>
+          </a:p>
+        </p:txBody>
+      </p:sp>
+      <p:sp>
+        <p:nvSpPr>
+          <p:cNvPr id="3" name="TextBox 2"/>
+          <p:cNvSpPr txBox="1"/>
+          <p:nvPr/>
+        </p:nvSpPr>
+        <p:spPr>
+          <a:xfrm>
+            <a:off x="658368" y="228600"/>
+            <a:ext cx="7315200" cy="365760"/>
+          </a:xfrm>
+          <a:prstGeom prst="rect">
+            <a:avLst/>
+          </a:prstGeom>
+          <a:noFill/>
+        </p:spPr>
+        <p:txBody>
+          <a:bodyPr wrap="none">
+            <a:spAutoFit/>
+          </a:bodyPr>
+          <a:lstStyle/>
+          <a:p>
+            <a:r>
+              <a:rPr sz="1300" b="1">
+                <a:solidFill>
+                  <a:srgbClr val="304B35"/>
+                </a:solidFill>
+                <a:latin typeface="Arial"/>
+              </a:rPr>
+              <a:t>RETOUR DÉVELOPPEUR</a:t>
+            </a:r>
+          </a:p>
+        </p:txBody>
+      </p:sp>
+      <p:sp>
+        <p:nvSpPr>
+          <p:cNvPr id="4" name="TextBox 3"/>
+          <p:cNvSpPr txBox="1"/>
+          <p:nvPr/>
+        </p:nvSpPr>
+        <p:spPr>
+          <a:xfrm>
+            <a:off x="640080" y="502920"/>
+            <a:ext cx="10881360" cy="914400"/>
+          </a:xfrm>
+          <a:prstGeom prst="rect">
+            <a:avLst/>
+          </a:prstGeom>
+          <a:noFill/>
+        </p:spPr>
+        <p:txBody>
+          <a:bodyPr wrap="square">
+            <a:spAutoFit/>
+          </a:bodyPr>
+          <a:lstStyle/>
+          <a:p>
+            <a:r>
+              <a:rPr sz="3400" b="1">
+                <a:solidFill>
+                  <a:srgbClr val="20271F"/>
+                </a:solidFill>
+                <a:latin typeface="Georgia"/>
+              </a:rPr>
+              <a:t>MCP (Model Context Protocol)</a:t>
+            </a:r>
+          </a:p>
+        </p:txBody>
+      </p:sp>
+      <p:sp>
+        <p:nvSpPr>
+          <p:cNvPr id="5" name="Rectangle 4"/>
+          <p:cNvSpPr/>
+          <p:nvPr/>
+        </p:nvSpPr>
+        <p:spPr>
+          <a:xfrm>
+            <a:off x="640080" y="1417320"/>
+            <a:ext cx="1280160" cy="50800"/>
+          </a:xfrm>
+          <a:prstGeom prst="rect">
+            <a:avLst/>
+          </a:prstGeom>
+          <a:solidFill>
+            <a:srgbClr val="304B35"/>
+          </a:solidFill>
+          <a:ln>
+            <a:noFill/>
+          </a:ln>
+          <a:effectLst/>
+        </p:spPr>
+        <p:style>
+          <a:lnRef idx="1">
+            <a:schemeClr val="accent1"/>
+          </a:lnRef>
+          <a:fillRef idx="3">
+            <a:schemeClr val="accent1"/>
+          </a:fillRef>
+          <a:effectRef idx="2">
+            <a:schemeClr val="accent1"/>
+          </a:effectRef>
+          <a:fontRef idx="minor">
+            <a:schemeClr val="lt1"/>
+          </a:fontRef>
+        </p:style>
+        <p:txBody>
+          <a:bodyPr rtlCol="0" anchor="ctr"/>
+          <a:lstStyle/>
+          <a:p>
+            <a:pPr algn="ctr"/>
+          </a:p>
+        </p:txBody>
+      </p:sp>
+      <p:sp>
+        <p:nvSpPr>
+          <p:cNvPr id="6" name="TextBox 5"/>
+          <p:cNvSpPr txBox="1"/>
+          <p:nvPr/>
+        </p:nvSpPr>
+        <p:spPr>
+          <a:xfrm>
+            <a:off x="640080" y="6446520"/>
+            <a:ext cx="10881360" cy="320040"/>
+          </a:xfrm>
+          <a:prstGeom prst="rect">
+            <a:avLst/>
+          </a:prstGeom>
+          <a:noFill/>
+        </p:spPr>
+        <p:txBody>
+          <a:bodyPr wrap="none">
+            <a:spAutoFit/>
+          </a:bodyPr>
+          <a:lstStyle/>
+          <a:p>
+            <a:r>
+              <a:rPr sz="1100">
+                <a:solidFill>
+                  <a:srgbClr val="6B7463"/>
+                </a:solidFill>
+                <a:latin typeface="Arial"/>
+              </a:rPr>
+              <a:t>Octro v2.2 — Track 1 Loaded</a:t>
+            </a:r>
+          </a:p>
+        </p:txBody>
+      </p:sp>
+      <p:sp>
+        <p:nvSpPr>
+          <p:cNvPr id="7" name="TextBox 6"/>
+          <p:cNvSpPr txBox="1"/>
+          <p:nvPr/>
+        </p:nvSpPr>
+        <p:spPr>
+          <a:xfrm>
+            <a:off x="685800" y="1920240"/>
+            <a:ext cx="10789920" cy="4389120"/>
+          </a:xfrm>
+          <a:prstGeom prst="rect">
+            <a:avLst/>
+          </a:prstGeom>
+          <a:noFill/>
+        </p:spPr>
+        <p:txBody>
+          <a:bodyPr wrap="square">
+            <a:spAutoFit/>
+          </a:bodyPr>
+          <a:lstStyle/>
+          <a:p>
+            <a:pPr>
+              <a:spcAft>
+                <a:spcPts val="1000"/>
+              </a:spcAft>
+            </a:pPr>
+            <a:r>
+              <a:rPr sz="2000" b="1">
+                <a:solidFill>
+                  <a:srgbClr val="20271F"/>
+                </a:solidFill>
+                <a:latin typeface="Arial"/>
+              </a:rPr>
+              <a:t>▸ 3 outils exposés, strictement en lecture</a:t>
+            </a:r>
+          </a:p>
+          <a:p>
+            <a:pPr lvl="1">
+              <a:spcAft>
+                <a:spcPts val="400"/>
+              </a:spcAft>
+            </a:pPr>
+            <a:r>
+              <a:rPr sz="1600" b="0">
+                <a:solidFill>
+                  <a:srgbClr val="304B35"/>
+                </a:solidFill>
+                <a:latin typeface="Arial"/>
+              </a:rPr>
+              <a:t>–  Résumé de compte, projection de trésorerie, explication de proposition</a:t>
+            </a:r>
+          </a:p>
+          <a:p>
+            <a:pPr>
+              <a:spcAft>
+                <a:spcPts val="1000"/>
+              </a:spcAft>
+            </a:pPr>
+            <a:r>
+              <a:rPr sz="2000" b="1">
+                <a:solidFill>
+                  <a:srgbClr val="20271F"/>
+                </a:solidFill>
+                <a:latin typeface="Arial"/>
+              </a:rPr>
+              <a:t>▸ Autorisation héritée de l'API métier (tenant, scope, jeton)</a:t>
+            </a:r>
+          </a:p>
+          <a:p>
+            <a:pPr lvl="1">
+              <a:spcAft>
+                <a:spcPts val="400"/>
+              </a:spcAft>
+            </a:pPr>
+            <a:r>
+              <a:rPr sz="1600" b="0">
+                <a:solidFill>
+                  <a:srgbClr val="304B35"/>
+                </a:solidFill>
+                <a:latin typeface="Arial"/>
+              </a:rPr>
+              <a:t>–  MCP ne constitue pas un second chemin d'autorisation ni une preuve de confiance en soi</a:t>
+            </a:r>
+          </a:p>
+          <a:p>
+            <a:pPr>
+              <a:spcAft>
+                <a:spcPts val="1000"/>
+              </a:spcAft>
+            </a:pPr>
+            <a:r>
+              <a:rPr sz="2000" b="1">
+                <a:solidFill>
+                  <a:srgbClr val="20271F"/>
+                </a:solidFill>
+                <a:latin typeface="Arial"/>
+              </a:rPr>
+              <a:t>▸ Signature et soumission XRPL : toujours hors du LLM et hors MCP</a:t>
+            </a:r>
+          </a:p>
+          <a:p>
+            <a:pPr>
+              <a:spcAft>
+                <a:spcPts val="1000"/>
+              </a:spcAft>
+            </a:pPr>
+            <a:r>
+              <a:rPr sz="2000" b="1">
+                <a:solidFill>
+                  <a:srgbClr val="20271F"/>
+                </a:solidFill>
+                <a:latin typeface="Arial"/>
+              </a:rPr>
+              <a:t>▸ Limite actuelle : réponses câblées en dur sur la fixture Lina</a:t>
+            </a:r>
+          </a:p>
+          <a:p>
+            <a:pPr lvl="1">
+              <a:spcAft>
+                <a:spcPts val="400"/>
+              </a:spcAft>
+            </a:pPr>
+            <a:r>
+              <a:rPr sz="1600" b="0">
+                <a:solidFill>
+                  <a:srgbClr val="304B35"/>
+                </a:solidFill>
+                <a:latin typeface="Arial"/>
+              </a:rPr>
+              <a:t>–  Pas encore branchées aux cas d'usage réels ni aux namespaces data.*/engine.* du CDC</a:t>
+            </a:r>
+          </a:p>
+        </p:txBody>
+      </p:sp>
+    </p:spTree>
+  </p:cSld>
+  <p:clrMapOvr>
+    <a:masterClrMapping/>
+  </p:clrMapOvr>
+</p:sld>
+</file>
+
+<file path=ppt/slides/slide9.xml><?xml version="1.0" encoding="utf-8"?>
 <p:sld xmlns:a="http://schemas.openxmlformats.org/drawingml/2006/main" xmlns:p="http://schemas.openxmlformats.org/presentationml/2006/main" xmlns:r="http://schemas.openxmlformats.org/officeDocument/2006/relationships">
   <p:cSld>
     <p:spTree>

</xml_diff>

<commit_message>
docs(presentation): simplify demo slide to a plain transition
Replace the bulleted demo walkthrough with a single full-screen "→ Démo"
transition slide, matching the section-break style used elsewhere in the
deck, since the actual walkthrough happens live rather than on-slide.

Co-Authored-By: Claude Sonnet 5 <noreply@anthropic.com>
Claude-Session: https://claude.ai/code/session_01GVjnCnga6LrWgo7YT1mivM
</commit_message>
<xml_diff>
--- a/docs/presentation/octro-presentation.pptx
+++ b/docs/presentation/octro-presentation.pptx
@@ -3978,7 +3978,7 @@
             <a:avLst/>
           </a:prstGeom>
           <a:solidFill>
-            <a:srgbClr val="F5F2E8"/>
+            <a:srgbClr val="304B35"/>
           </a:solidFill>
           <a:ln>
             <a:noFill/>
@@ -4015,8 +4015,8 @@
         </p:nvSpPr>
         <p:spPr>
           <a:xfrm>
-            <a:off x="658368" y="228600"/>
-            <a:ext cx="7315200" cy="365760"/>
+            <a:off x="822960" y="2880360"/>
+            <a:ext cx="10515600" cy="1463040"/>
           </a:xfrm>
           <a:prstGeom prst="rect">
             <a:avLst/>
@@ -4029,245 +4029,15 @@
           </a:bodyPr>
           <a:lstStyle/>
           <a:p>
-            <a:r>
-              <a:rPr sz="1300" b="1">
-                <a:solidFill>
-                  <a:srgbClr val="304B35"/>
-                </a:solidFill>
-                <a:latin typeface="Arial"/>
-              </a:rPr>
-              <a:t>DÉMONSTRATION</a:t>
-            </a:r>
-          </a:p>
-        </p:txBody>
-      </p:sp>
-      <p:sp>
-        <p:nvSpPr>
-          <p:cNvPr id="4" name="TextBox 3"/>
-          <p:cNvSpPr txBox="1"/>
-          <p:nvPr/>
-        </p:nvSpPr>
-        <p:spPr>
-          <a:xfrm>
-            <a:off x="640080" y="502920"/>
-            <a:ext cx="10881360" cy="914400"/>
-          </a:xfrm>
-          <a:prstGeom prst="rect">
-            <a:avLst/>
-          </a:prstGeom>
-          <a:noFill/>
-        </p:spPr>
-        <p:txBody>
-          <a:bodyPr wrap="square">
-            <a:spAutoFit/>
-          </a:bodyPr>
-          <a:lstStyle/>
-          <a:p>
-            <a:r>
-              <a:rPr sz="3400" b="1">
-                <a:solidFill>
-                  <a:srgbClr val="20271F"/>
+            <a:pPr algn="ctr"/>
+            <a:r>
+              <a:rPr sz="6000" b="1">
+                <a:solidFill>
+                  <a:srgbClr val="F5F2E8"/>
                 </a:solidFill>
                 <a:latin typeface="Georgia"/>
               </a:rPr>
-              <a:t>→ On bascule sur la démo live</a:t>
-            </a:r>
-          </a:p>
-        </p:txBody>
-      </p:sp>
-      <p:sp>
-        <p:nvSpPr>
-          <p:cNvPr id="5" name="Rectangle 4"/>
-          <p:cNvSpPr/>
-          <p:nvPr/>
-        </p:nvSpPr>
-        <p:spPr>
-          <a:xfrm>
-            <a:off x="640080" y="1417320"/>
-            <a:ext cx="1280160" cy="50800"/>
-          </a:xfrm>
-          <a:prstGeom prst="rect">
-            <a:avLst/>
-          </a:prstGeom>
-          <a:solidFill>
-            <a:srgbClr val="304B35"/>
-          </a:solidFill>
-          <a:ln>
-            <a:noFill/>
-          </a:ln>
-          <a:effectLst/>
-        </p:spPr>
-        <p:style>
-          <a:lnRef idx="1">
-            <a:schemeClr val="accent1"/>
-          </a:lnRef>
-          <a:fillRef idx="3">
-            <a:schemeClr val="accent1"/>
-          </a:fillRef>
-          <a:effectRef idx="2">
-            <a:schemeClr val="accent1"/>
-          </a:effectRef>
-          <a:fontRef idx="minor">
-            <a:schemeClr val="lt1"/>
-          </a:fontRef>
-        </p:style>
-        <p:txBody>
-          <a:bodyPr rtlCol="0" anchor="ctr"/>
-          <a:lstStyle/>
-          <a:p>
-            <a:pPr algn="ctr"/>
-          </a:p>
-        </p:txBody>
-      </p:sp>
-      <p:sp>
-        <p:nvSpPr>
-          <p:cNvPr id="6" name="TextBox 5"/>
-          <p:cNvSpPr txBox="1"/>
-          <p:nvPr/>
-        </p:nvSpPr>
-        <p:spPr>
-          <a:xfrm>
-            <a:off x="640080" y="6446520"/>
-            <a:ext cx="10881360" cy="320040"/>
-          </a:xfrm>
-          <a:prstGeom prst="rect">
-            <a:avLst/>
-          </a:prstGeom>
-          <a:noFill/>
-        </p:spPr>
-        <p:txBody>
-          <a:bodyPr wrap="none">
-            <a:spAutoFit/>
-          </a:bodyPr>
-          <a:lstStyle/>
-          <a:p>
-            <a:r>
-              <a:rPr sz="1100">
-                <a:solidFill>
-                  <a:srgbClr val="6B7463"/>
-                </a:solidFill>
-                <a:latin typeface="Arial"/>
-              </a:rPr>
-              <a:t>Octro v2.2 — Track 1 Loaded</a:t>
-            </a:r>
-          </a:p>
-        </p:txBody>
-      </p:sp>
-      <p:sp>
-        <p:nvSpPr>
-          <p:cNvPr id="7" name="TextBox 6"/>
-          <p:cNvSpPr txBox="1"/>
-          <p:nvPr/>
-        </p:nvSpPr>
-        <p:spPr>
-          <a:xfrm>
-            <a:off x="685800" y="1920240"/>
-            <a:ext cx="10789920" cy="4389120"/>
-          </a:xfrm>
-          <a:prstGeom prst="rect">
-            <a:avLst/>
-          </a:prstGeom>
-          <a:noFill/>
-        </p:spPr>
-        <p:txBody>
-          <a:bodyPr wrap="square">
-            <a:spAutoFit/>
-          </a:bodyPr>
-          <a:lstStyle/>
-          <a:p>
-            <a:pPr>
-              <a:spcAft>
-                <a:spcPts val="1000"/>
-              </a:spcAft>
-            </a:pPr>
-            <a:r>
-              <a:rPr sz="2100" b="1">
-                <a:solidFill>
-                  <a:srgbClr val="20271F"/>
-                </a:solidFill>
-                <a:latin typeface="Arial"/>
-              </a:rPr>
-              <a:t>▸ Calendrier personnel (Lina) : manque détecté avant l'échéance</a:t>
-            </a:r>
-          </a:p>
-          <a:p>
-            <a:pPr lvl="1">
-              <a:spcAft>
-                <a:spcPts val="400"/>
-              </a:spcAft>
-            </a:pPr>
-            <a:r>
-              <a:rPr sz="1600" b="0">
-                <a:solidFill>
-                  <a:srgbClr val="304B35"/>
-                </a:solidFill>
-                <a:latin typeface="Arial"/>
-              </a:rPr>
-              <a:t>–  Réserve protégée visible, proposition de transfert de fonds propres sans dette</a:t>
-            </a:r>
-          </a:p>
-          <a:p>
-            <a:pPr>
-              <a:spcAft>
-                <a:spcPts val="1000"/>
-              </a:spcAft>
-            </a:pPr>
-            <a:r>
-              <a:rPr sz="2100" b="1">
-                <a:solidFill>
-                  <a:srgbClr val="20271F"/>
-                </a:solidFill>
-                <a:latin typeface="Arial"/>
-              </a:rPr>
-              <a:t>▸ Cas indépendant / organisation : retard de règlement, comparaison d'options</a:t>
-            </a:r>
-          </a:p>
-          <a:p>
-            <a:pPr>
-              <a:spcAft>
-                <a:spcPts val="1000"/>
-              </a:spcAft>
-            </a:pPr>
-            <a:r>
-              <a:rPr sz="2100" b="1">
-                <a:solidFill>
-                  <a:srgbClr val="20271F"/>
-                </a:solidFill>
-                <a:latin typeface="Arial"/>
-              </a:rPr>
-              <a:t>▸ Cycle de prêt réel sur le Custom Hackathon Devnet</a:t>
-            </a:r>
-          </a:p>
-          <a:p>
-            <a:pPr lvl="1">
-              <a:spcAft>
-                <a:spcPts val="400"/>
-              </a:spcAft>
-            </a:pPr>
-            <a:r>
-              <a:rPr sz="1600" b="0">
-                <a:solidFill>
-                  <a:srgbClr val="304B35"/>
-                </a:solidFill>
-                <a:latin typeface="Arial"/>
-              </a:rPr>
-              <a:t>–  Vault → dépôt → courtier → prêt accepté → décaissement → remboursement → retrait avec rendement</a:t>
-            </a:r>
-          </a:p>
-          <a:p>
-            <a:pPr>
-              <a:spcAft>
-                <a:spcPts val="1000"/>
-              </a:spcAft>
-            </a:pPr>
-            <a:r>
-              <a:rPr sz="2100" b="1">
-                <a:solidFill>
-                  <a:srgbClr val="20271F"/>
-                </a:solidFill>
-                <a:latin typeface="Arial"/>
-              </a:rPr>
-              <a:t>▸ Contrôle d'accès Credentials/Domains : refus sans attestation, acceptation avec attestation</a:t>
+              <a:t>→ Démo</a:t>
             </a:r>
           </a:p>
         </p:txBody>

</xml_diff>

<commit_message>
docs(presentation): translate deck to English
Full English translation of all 10 slides (title, subject, demo transition,
connectors, developer feedback section and its four topic slides,
potential), content unchanged.

Co-Authored-By: Claude Sonnet 5 <noreply@anthropic.com>
Claude-Session: https://claude.ai/code/session_01GVjnCnga6LrWgo7YT1mivM
</commit_message>
<xml_diff>
--- a/docs/presentation/octro-presentation.pptx
+++ b/docs/presentation/octro-presentation.pptx
@@ -3204,7 +3204,7 @@
                 </a:solidFill>
                 <a:latin typeface="Arial"/>
               </a:rPr>
-              <a:t>Anticiper un manque de trésorerie, choisir sans dette d'abord, exécuter sur XRPL quand c'est nécessaire.</a:t>
+              <a:t>See a cash shortfall coming, choose no-debt options first, execute on XRPL only when it's actually needed.</a:t>
             </a:r>
           </a:p>
         </p:txBody>
@@ -3334,7 +3334,7 @@
                 </a:solidFill>
                 <a:latin typeface="Arial"/>
               </a:rPr>
-              <a:t>POTENTIEL</a:t>
+              <a:t>POTENTIAL</a:t>
             </a:r>
           </a:p>
         </p:txBody>
@@ -3368,7 +3368,7 @@
                 </a:solidFill>
                 <a:latin typeface="Georgia"/>
               </a:rPr>
-              <a:t>Un chemin par capacité, pas une promesse</a:t>
+              <a:t>A path by capability, not a promise</a:t>
             </a:r>
           </a:p>
         </p:txBody>
@@ -3485,7 +3485,7 @@
                 </a:solidFill>
                 <a:latin typeface="Arial"/>
               </a:rPr>
-              <a:t>▸ Semaines 1-2 : stabiliser les adaptateurs, tester l'utilité avec particuliers et indépendants</a:t>
+              <a:t>▸ Weeks 1-2: stabilize the adapters, test usefulness with individuals and freelancers</a:t>
             </a:r>
           </a:p>
           <a:p>
@@ -3501,7 +3501,7 @@
                 </a:solidFill>
                 <a:latin typeface="Arial"/>
               </a:rPr>
-              <a:t>▸ Semaines 3-6 : connecteurs autorisés, backtests, instrumentation du risque</a:t>
+              <a:t>▸ Weeks 3-6: authorized connectors, backtests, risk instrumentation</a:t>
             </a:r>
           </a:p>
           <a:p>
@@ -3517,7 +3517,7 @@
                 </a:solidFill>
                 <a:latin typeface="Arial"/>
               </a:rPr>
-              <a:t>▸ Semaines 7-12 : pilote par capacité et juridiction validées</a:t>
+              <a:t>▸ Weeks 7-12: pilot by validated capability and jurisdiction</a:t>
             </a:r>
           </a:p>
           <a:p>
@@ -3533,7 +3533,7 @@
                 </a:solidFill>
                 <a:latin typeface="Arial"/>
               </a:rPr>
-              <a:t>▸ Modèle économique proposé</a:t>
+              <a:t>▸ Proposed business model</a:t>
             </a:r>
           </a:p>
           <a:p>
@@ -3549,7 +3549,7 @@
                 </a:solidFill>
                 <a:latin typeface="Arial"/>
               </a:rPr>
-              <a:t>–  Socle personnel gratuit (saisie, calendrier, simulation) ; abonnement facultatif pour automatisations avancées ; offre équipe/API</a:t>
+              <a:t>–  Free personal baseline (entry, calendar, simulation); optional subscription for advanced automations; team/API offering</a:t>
             </a:r>
           </a:p>
           <a:p>
@@ -3565,7 +3565,7 @@
                 </a:solidFill>
                 <a:latin typeface="Arial"/>
               </a:rPr>
-              <a:t>▸ Machine learning post-hackathon</a:t>
+              <a:t>▸ Machine learning, post-hackathon</a:t>
             </a:r>
           </a:p>
           <a:p>
@@ -3581,7 +3581,7 @@
                 </a:solidFill>
                 <a:latin typeface="Arial"/>
               </a:rPr>
-              <a:t>–  Estimation des délais et défauts par historique autorisé, séparation entraînement/validation, comparée à une baseline calendrier avant d'être retenue</a:t>
+              <a:t>–  Estimating delays and defaults from authorized history, train/validation separation, benchmarked against a calendar baseline before being adopted</a:t>
             </a:r>
           </a:p>
           <a:p>
@@ -3597,7 +3597,7 @@
                 </a:solidFill>
                 <a:latin typeface="Arial"/>
               </a:rPr>
-              <a:t>▸ Sponsoring, DID et connecteurs avancent selon les résultats de recette, jamais selon une promesse de disponibilité mondiale</a:t>
+              <a:t>▸ Sponsorship, DID and connectors advance based on acceptance-test results, never on a promise of global availability</a:t>
             </a:r>
           </a:p>
         </p:txBody>
@@ -3693,7 +3693,7 @@
                 </a:solidFill>
                 <a:latin typeface="Arial"/>
               </a:rPr>
-              <a:t>LE SUJET</a:t>
+              <a:t>THE SUBJECT</a:t>
             </a:r>
           </a:p>
         </p:txBody>
@@ -3727,7 +3727,7 @@
                 </a:solidFill>
                 <a:latin typeface="Georgia"/>
               </a:rPr>
-              <a:t>Un moteur, trois publics, une même promesse</a:t>
+              <a:t>One engine, three audiences, one promise</a:t>
             </a:r>
           </a:p>
         </p:txBody>
@@ -3844,7 +3844,7 @@
                 </a:solidFill>
                 <a:latin typeface="Arial"/>
               </a:rPr>
-              <a:t>▸ Octro rapproche l'argent disponible, les revenus attendus et les dépenses à venir</a:t>
+              <a:t>▸ Octro brings together available cash, expected income, and upcoming expenses</a:t>
             </a:r>
           </a:p>
           <a:p>
@@ -3860,7 +3860,7 @@
                 </a:solidFill>
                 <a:latin typeface="Arial"/>
               </a:rPr>
-              <a:t>–  Particuliers, indépendants et organisations sur le même moteur de coordination financière</a:t>
+              <a:t>–  Individuals, freelancers, and organizations run on the same financial coordination engine</a:t>
             </a:r>
           </a:p>
           <a:p>
@@ -3876,7 +3876,7 @@
                 </a:solidFill>
                 <a:latin typeface="Arial"/>
               </a:rPr>
-              <a:t>▸ La première question n'est jamais le crédit</a:t>
+              <a:t>▸ The first question is never credit</a:t>
             </a:r>
           </a:p>
           <a:p>
@@ -3892,7 +3892,7 @@
                 </a:solidFill>
                 <a:latin typeface="Arial"/>
               </a:rPr>
-              <a:t>–  Priorité aux fonds propres et aux ajustements sans dette avant toute comparaison de financement</a:t>
+              <a:t>–  Priority to own funds and no-debt adjustments before any financing comparison</a:t>
             </a:r>
           </a:p>
           <a:p>
@@ -3908,7 +3908,7 @@
                 </a:solidFill>
                 <a:latin typeface="Arial"/>
               </a:rPr>
-              <a:t>▸ Le crédit XRPL n'intervient que lorsqu'il est réellement pertinent</a:t>
+              <a:t>▸ XRPL credit only steps in when it's genuinely relevant</a:t>
             </a:r>
           </a:p>
           <a:p>
@@ -3924,7 +3924,7 @@
                 </a:solidFill>
                 <a:latin typeface="Arial"/>
               </a:rPr>
-              <a:t>–  Track 1 Loaded : cycle de prêt XLS-65/66 avec Credentials &amp; Permissioned Domains sur un vault privé</a:t>
+              <a:t>–  Track 1 Loaded: XLS-65/66 loan cycle with Credentials &amp; Permissioned Domains on a private vault</a:t>
             </a:r>
           </a:p>
           <a:p>
@@ -3940,7 +3940,7 @@
                 </a:solidFill>
                 <a:latin typeface="Arial"/>
               </a:rPr>
-              <a:t>▸ Workspace personnel sans Organization, sans wallet, sans crédit obligatoire</a:t>
+              <a:t>▸ Personal workspace with no Organization, no wallet, no credit required</a:t>
             </a:r>
           </a:p>
         </p:txBody>
@@ -4037,7 +4037,7 @@
                 </a:solidFill>
                 <a:latin typeface="Georgia"/>
               </a:rPr>
-              <a:t>→ Démo</a:t>
+              <a:t>→ Demo</a:t>
             </a:r>
           </a:p>
         </p:txBody>
@@ -4133,7 +4133,7 @@
                 </a:solidFill>
                 <a:latin typeface="Arial"/>
               </a:rPr>
-              <a:t>OÙ OCTRO PEUT S'INTÉGRER</a:t>
+              <a:t>WHERE OCTRO CAN PLUG IN</a:t>
             </a:r>
           </a:p>
         </p:txBody>
@@ -4167,7 +4167,7 @@
                 </a:solidFill>
                 <a:latin typeface="Georgia"/>
               </a:rPr>
-              <a:t>Des connecteurs candidats, pas acquis</a:t>
+              <a:t>Candidate connectors, not acquired integrations</a:t>
             </a:r>
           </a:p>
         </p:txBody>
@@ -4284,7 +4284,7 @@
                 </a:solidFill>
                 <a:latin typeface="Arial"/>
               </a:rPr>
-              <a:t>▸ Mobile money (pays africains), UPI (Inde), PIX (Brésil), banque européenne, PSP international</a:t>
+              <a:t>▸ Mobile money (African countries), UPI (India), PIX (Brazil), European banking, international PSPs</a:t>
             </a:r>
           </a:p>
           <a:p>
@@ -4300,7 +4300,7 @@
                 </a:solidFill>
                 <a:latin typeface="Arial"/>
               </a:rPr>
-              <a:t>–  Familles de connecteurs candidates ; langue, faible débit, formats et capacités locales traités indépendamment</a:t>
+              <a:t>–  Candidate connector families; language, low bandwidth, formats and local capabilities handled independently</a:t>
             </a:r>
           </a:p>
           <a:p>
@@ -4316,7 +4316,7 @@
                 </a:solidFill>
                 <a:latin typeface="Arial"/>
               </a:rPr>
-              <a:t>▸ Sans connecteur local : saisie manuelle et import restent toujours possibles</a:t>
+              <a:t>▸ No local connector: manual entry and import always remain available</a:t>
             </a:r>
           </a:p>
           <a:p>
@@ -4332,7 +4332,7 @@
                 </a:solidFill>
                 <a:latin typeface="Arial"/>
               </a:rPr>
-              <a:t>–  Le socle personnel reste utile même quand le financement ou la connexion sont indisponibles</a:t>
+              <a:t>–  The personal baseline stays useful even when financing or a connection is unavailable</a:t>
             </a:r>
           </a:p>
           <a:p>
@@ -4348,7 +4348,7 @@
                 </a:solidFill>
                 <a:latin typeface="Arial"/>
               </a:rPr>
-              <a:t>▸ Disponibilité évaluée par capacité et par juridiction, jamais globale par défaut</a:t>
+              <a:t>▸ Availability assessed by capability and jurisdiction, never global by default</a:t>
             </a:r>
           </a:p>
           <a:p>
@@ -4364,7 +4364,7 @@
                 </a:solidFill>
                 <a:latin typeface="Arial"/>
               </a:rPr>
-              <a:t>–  Matrice séparée pour analyse / connexion / transfert / financement — « mondial » ne veut pas dire que tous les rails fonctionnent partout</a:t>
+              <a:t>–  Separate matrix for analysis / connection / transfer / financing — “global” doesn't mean every rail works everywhere</a:t>
             </a:r>
           </a:p>
         </p:txBody>
@@ -4460,7 +4460,7 @@
                 </a:solidFill>
                 <a:latin typeface="Georgia"/>
               </a:rPr>
-              <a:t>Retour développeur — points clés</a:t>
+              <a:t>Developer feedback — key points</a:t>
             </a:r>
           </a:p>
         </p:txBody>
@@ -4494,7 +4494,7 @@
                 </a:solidFill>
                 <a:latin typeface="Arial"/>
               </a:rPr>
-              <a:t>Algorithmes  ·  Orchestration agentique  ·  MCP  ·  Machine learning</a:t>
+              <a:t>Algorithms  ·  Agentic orchestration  ·  MCP  ·  Machine learning</a:t>
             </a:r>
           </a:p>
         </p:txBody>
@@ -4590,7 +4590,7 @@
                 </a:solidFill>
                 <a:latin typeface="Arial"/>
               </a:rPr>
-              <a:t>RETOUR DÉVELOPPEUR</a:t>
+              <a:t>DEVELOPER FEEDBACK</a:t>
             </a:r>
           </a:p>
         </p:txBody>
@@ -4624,7 +4624,7 @@
                 </a:solidFill>
                 <a:latin typeface="Georgia"/>
               </a:rPr>
-              <a:t>Algorithmes utilisés</a:t>
+              <a:t>Algorithms used</a:t>
             </a:r>
           </a:p>
         </p:txBody>
@@ -4741,7 +4741,7 @@
                 </a:solidFill>
                 <a:latin typeface="Arial"/>
               </a:rPr>
-              <a:t>▸ CVaR — forme fermée de Rockafellar–Uryasev</a:t>
+              <a:t>▸ CVaR — closed form (Rockafellar–Uryasev)</a:t>
             </a:r>
           </a:p>
           <a:p>
@@ -4757,7 +4757,7 @@
                 </a:solidFill>
                 <a:latin typeface="Arial"/>
               </a:rPr>
-              <a:t>–  Vérifié sur la fixture CDC : pertes [0,0,100], poids [0,80 ; 0,15 ; 0,05] → CVaR95 = 100</a:t>
+              <a:t>–  Verified against the CDC fixture: losses [0,0,100], weights [0.80, 0.15, 0.05] → CVaR95 = 100</a:t>
             </a:r>
           </a:p>
           <a:p>
@@ -4773,7 +4773,7 @@
                 </a:solidFill>
                 <a:latin typeface="Arial"/>
               </a:rPr>
-              <a:t>▸ Moteur personnel sans dette</a:t>
+              <a:t>▸ Personal no-debt engine</a:t>
             </a:r>
           </a:p>
           <a:p>
@@ -4789,7 +4789,7 @@
                 </a:solidFill>
                 <a:latin typeface="Arial"/>
               </a:rPr>
-              <a:t>–  Réserve protégée en contrainte dure, jamais relâchée automatiquement ; montant revérifié après arrondi</a:t>
+              <a:t>–  Protected reserve as a hard constraint, never auto-relaxed; amount re-checked after rounding</a:t>
             </a:r>
           </a:p>
           <a:p>
@@ -4805,7 +4805,7 @@
                 </a:solidFill>
                 <a:latin typeface="Arial"/>
               </a:rPr>
-              <a:t>▸ Allocation de financement</a:t>
+              <a:t>▸ Financing allocation</a:t>
             </a:r>
           </a:p>
           <a:p>
@@ -4821,7 +4821,7 @@
                 </a:solidFill>
                 <a:latin typeface="Arial"/>
               </a:rPr>
-              <a:t>–  Offre la moins chère d'abord (glouton), dette terminale conservée au-delà de l'horizon</a:t>
+              <a:t>–  Cheapest offer first (greedy), terminal debt kept past the horizon</a:t>
             </a:r>
           </a:p>
           <a:p>
@@ -4837,7 +4837,7 @@
                 </a:solidFill>
                 <a:latin typeface="Arial"/>
               </a:rPr>
-              <a:t>▸ Pas encore de solveur LP/MILP unifié (scipy/HiGHS)</a:t>
+              <a:t>▸ No unified LP/MILP solver yet (scipy/HiGHS)</a:t>
             </a:r>
           </a:p>
           <a:p>
@@ -4853,7 +4853,7 @@
                 </a:solidFill>
                 <a:latin typeface="Arial"/>
               </a:rPr>
-              <a:t>–  Chaque garantie du CDC est prouvée sur les scénarios de démo, pas sur un plan combiné multi-actifs</a:t>
+              <a:t>–  Every CDC guarantee is proven on the demo scenarios, not on a combined multi-asset plan</a:t>
             </a:r>
           </a:p>
         </p:txBody>
@@ -4949,7 +4949,7 @@
                 </a:solidFill>
                 <a:latin typeface="Arial"/>
               </a:rPr>
-              <a:t>RETOUR DÉVELOPPEUR</a:t>
+              <a:t>DEVELOPER FEEDBACK</a:t>
             </a:r>
           </a:p>
         </p:txBody>
@@ -4983,7 +4983,7 @@
                 </a:solidFill>
                 <a:latin typeface="Georgia"/>
               </a:rPr>
-              <a:t>Orchestration agentique</a:t>
+              <a:t>Agentic orchestration</a:t>
             </a:r>
           </a:p>
         </p:txBody>
@@ -5100,7 +5100,7 @@
                 </a:solidFill>
                 <a:latin typeface="Arial"/>
               </a:rPr>
-              <a:t>▸ Coordinateur borné : maximum 12 appels d'outils (AGT-01)</a:t>
+              <a:t>▸ Bounded coordinator: 12 tool calls maximum (AGT-01)</a:t>
             </a:r>
           </a:p>
           <a:p>
@@ -5116,7 +5116,7 @@
                 </a:solidFill>
                 <a:latin typeface="Arial"/>
               </a:rPr>
-              <a:t>▸ Aucun outil de signature ou de soumission accessible au LLM (AGT-02)</a:t>
+              <a:t>▸ No signing or submission tool ever reachable by the LLM (AGT-02)</a:t>
             </a:r>
           </a:p>
           <a:p>
@@ -5132,7 +5132,7 @@
                 </a:solidFill>
                 <a:latin typeface="Arial"/>
               </a:rPr>
-              <a:t>▸ Bascule déterministe si le fournisseur LLM est indisponible (AGT-03)</a:t>
+              <a:t>▸ Deterministic fallback if the LLM provider is unavailable (AGT-03)</a:t>
             </a:r>
           </a:p>
           <a:p>
@@ -5148,7 +5148,7 @@
                 </a:solidFill>
                 <a:latin typeface="Arial"/>
               </a:rPr>
-              <a:t>▸ Implémentation actuelle : raccourci à 2 appels (analyse + explication)</a:t>
+              <a:t>▸ Current implementation: a 2-call shortcut (analyze + explain)</a:t>
             </a:r>
           </a:p>
           <a:p>
@@ -5164,7 +5164,7 @@
                 </a:solidFill>
                 <a:latin typeface="Arial"/>
               </a:rPr>
-              <a:t>–  Pas encore le graphe complet à 6 étapes du CDC : collecter → analyser → simuler → expliquer → attendre décision → suivre</a:t>
+              <a:t>–  Not yet the CDC's full 6-stage graph: collect → analyze → simulate → explain → await decision → follow up</a:t>
             </a:r>
           </a:p>
         </p:txBody>
@@ -5260,7 +5260,7 @@
                 </a:solidFill>
                 <a:latin typeface="Arial"/>
               </a:rPr>
-              <a:t>RETOUR DÉVELOPPEUR</a:t>
+              <a:t>DEVELOPER FEEDBACK</a:t>
             </a:r>
           </a:p>
         </p:txBody>
@@ -5411,7 +5411,7 @@
                 </a:solidFill>
                 <a:latin typeface="Arial"/>
               </a:rPr>
-              <a:t>▸ 3 outils exposés, strictement en lecture</a:t>
+              <a:t>▸ 3 tools exposed, strictly read-only</a:t>
             </a:r>
           </a:p>
           <a:p>
@@ -5427,7 +5427,7 @@
                 </a:solidFill>
                 <a:latin typeface="Arial"/>
               </a:rPr>
-              <a:t>–  Résumé de compte, projection de trésorerie, explication de proposition</a:t>
+              <a:t>–  Account summary, cash-flow projection, proposal explanation</a:t>
             </a:r>
           </a:p>
           <a:p>
@@ -5443,7 +5443,7 @@
                 </a:solidFill>
                 <a:latin typeface="Arial"/>
               </a:rPr>
-              <a:t>▸ Autorisation héritée de l'API métier (tenant, scope, jeton)</a:t>
+              <a:t>▸ Authorization inherited from the business API (tenant, scope, token)</a:t>
             </a:r>
           </a:p>
           <a:p>
@@ -5459,7 +5459,7 @@
                 </a:solidFill>
                 <a:latin typeface="Arial"/>
               </a:rPr>
-              <a:t>–  MCP ne constitue pas un second chemin d'autorisation ni une preuve de confiance en soi</a:t>
+              <a:t>–  MCP is not a second authorization path, nor proof of trust on its own</a:t>
             </a:r>
           </a:p>
           <a:p>
@@ -5475,7 +5475,7 @@
                 </a:solidFill>
                 <a:latin typeface="Arial"/>
               </a:rPr>
-              <a:t>▸ Signature et soumission XRPL : toujours hors du LLM et hors MCP</a:t>
+              <a:t>▸ XRPL signing and submission: always outside the LLM and outside MCP</a:t>
             </a:r>
           </a:p>
           <a:p>
@@ -5491,7 +5491,7 @@
                 </a:solidFill>
                 <a:latin typeface="Arial"/>
               </a:rPr>
-              <a:t>▸ Limite actuelle : réponses câblées en dur sur la fixture Lina</a:t>
+              <a:t>▸ Current limitation: responses are hardcoded on the Lina fixture</a:t>
             </a:r>
           </a:p>
           <a:p>
@@ -5507,7 +5507,7 @@
                 </a:solidFill>
                 <a:latin typeface="Arial"/>
               </a:rPr>
-              <a:t>–  Pas encore branchées aux cas d'usage réels ni aux namespaces data.*/engine.* du CDC</a:t>
+              <a:t>–  Not yet wired to real use cases or to the CDC's data.*/engine.* namespaces</a:t>
             </a:r>
           </a:p>
         </p:txBody>
@@ -5603,7 +5603,7 @@
                 </a:solidFill>
                 <a:latin typeface="Arial"/>
               </a:rPr>
-              <a:t>RETOUR DÉVELOPPEUR</a:t>
+              <a:t>DEVELOPER FEEDBACK</a:t>
             </a:r>
           </a:p>
         </p:txBody>
@@ -5754,7 +5754,7 @@
                 </a:solidFill>
                 <a:latin typeface="Arial"/>
               </a:rPr>
-              <a:t>▸ Aucun modèle génératif n'invente une probabilité d'encaissement</a:t>
+              <a:t>▸ No generative model invents a settlement probability</a:t>
             </a:r>
           </a:p>
           <a:p>
@@ -5770,7 +5770,7 @@
                 </a:solidFill>
                 <a:latin typeface="Arial"/>
               </a:rPr>
-              <a:t>▸ Poids de scénarios déclarés et fixes (0,80 / 0,15 / 0,05), affichés comme hypothèses</a:t>
+              <a:t>▸ Scenario weights are declared and fixed (0.80 / 0.15 / 0.05), shown as assumptions</a:t>
             </a:r>
           </a:p>
           <a:p>
@@ -5786,7 +5786,7 @@
                 </a:solidFill>
                 <a:latin typeface="Arial"/>
               </a:rPr>
-              <a:t>▸ Le LLM explique un plan déjà calculé, il ne le recalcule pas</a:t>
+              <a:t>▸ The LLM explains an already-computed plan, it doesn't recompute it</a:t>
             </a:r>
           </a:p>
           <a:p>
@@ -5802,7 +5802,7 @@
                 </a:solidFill>
                 <a:latin typeface="Arial"/>
               </a:rPr>
-              <a:t>–  Les chiffres affichés proviennent du moteur déterministe, jamais du texte généré</a:t>
+              <a:t>–  Displayed figures come from the deterministic engine, never from generated text</a:t>
             </a:r>
           </a:p>
           <a:p>
@@ -5818,7 +5818,7 @@
                 </a:solidFill>
                 <a:latin typeface="Arial"/>
               </a:rPr>
-              <a:t>▸ Estimation ML des délais/défauts par historique : hors MVP</a:t>
+              <a:t>▸ ML estimation of delays/defaults from history: out of scope for the MVP</a:t>
             </a:r>
           </a:p>
           <a:p>
@@ -5834,7 +5834,7 @@
                 </a:solidFill>
                 <a:latin typeface="Arial"/>
               </a:rPr>
-              <a:t>–  Prévue post-hackathon, avec séparation entraînement/validation et tests de calibration</a:t>
+              <a:t>–  Planned post-hackathon, with train/validation separation and calibration tests</a:t>
             </a:r>
           </a:p>
         </p:txBody>

</xml_diff>

<commit_message>
docs(presentation): condense feedback slides into one, drop Potential
Merge the four separate developer-feedback slides (algorithms, agentic
orchestration, MCP, machine learning) into a single 2x2 grid slide, and
remove the closing Potential slide. Deck is now 6 slides.

Co-Authored-By: Claude Sonnet 5 <noreply@anthropic.com>
Claude-Session: https://claude.ai/code/session_01GVjnCnga6LrWgo7YT1mivM
</commit_message>
<xml_diff>
--- a/docs/presentation/octro-presentation.pptx
+++ b/docs/presentation/octro-presentation.pptx
@@ -11,10 +11,6 @@
     <p:sldId id="259" r:id="rId10"/>
     <p:sldId id="260" r:id="rId11"/>
     <p:sldId id="261" r:id="rId12"/>
-    <p:sldId id="262" r:id="rId13"/>
-    <p:sldId id="263" r:id="rId14"/>
-    <p:sldId id="264" r:id="rId15"/>
-    <p:sldId id="265" r:id="rId16"/>
   </p:sldIdLst>
   <p:sldSz cx="12191695" cy="6858000" type="screen4x3"/>
   <p:notesSz cx="6858000" cy="9144000"/>
@@ -3251,365 +3247,6 @@
 </p:sld>
 </file>
 
-<file path=ppt/slides/slide10.xml><?xml version="1.0" encoding="utf-8"?>
-<p:sld xmlns:a="http://schemas.openxmlformats.org/drawingml/2006/main" xmlns:p="http://schemas.openxmlformats.org/presentationml/2006/main" xmlns:r="http://schemas.openxmlformats.org/officeDocument/2006/relationships">
-  <p:cSld>
-    <p:spTree>
-      <p:nvGrpSpPr>
-        <p:cNvPr id="1" name=""/>
-        <p:cNvGrpSpPr/>
-        <p:nvPr/>
-      </p:nvGrpSpPr>
-      <p:grpSpPr/>
-      <p:sp>
-        <p:nvSpPr>
-          <p:cNvPr id="2" name="Rectangle 1"/>
-          <p:cNvSpPr/>
-          <p:nvPr/>
-        </p:nvSpPr>
-        <p:spPr>
-          <a:xfrm>
-            <a:off x="0" y="0"/>
-            <a:ext cx="12191695" cy="6858000"/>
-          </a:xfrm>
-          <a:prstGeom prst="rect">
-            <a:avLst/>
-          </a:prstGeom>
-          <a:solidFill>
-            <a:srgbClr val="F5F2E8"/>
-          </a:solidFill>
-          <a:ln>
-            <a:noFill/>
-          </a:ln>
-          <a:effectLst/>
-        </p:spPr>
-        <p:style>
-          <a:lnRef idx="1">
-            <a:schemeClr val="accent1"/>
-          </a:lnRef>
-          <a:fillRef idx="3">
-            <a:schemeClr val="accent1"/>
-          </a:fillRef>
-          <a:effectRef idx="2">
-            <a:schemeClr val="accent1"/>
-          </a:effectRef>
-          <a:fontRef idx="minor">
-            <a:schemeClr val="lt1"/>
-          </a:fontRef>
-        </p:style>
-        <p:txBody>
-          <a:bodyPr rtlCol="0" anchor="ctr"/>
-          <a:lstStyle/>
-          <a:p>
-            <a:pPr algn="ctr"/>
-          </a:p>
-        </p:txBody>
-      </p:sp>
-      <p:sp>
-        <p:nvSpPr>
-          <p:cNvPr id="3" name="TextBox 2"/>
-          <p:cNvSpPr txBox="1"/>
-          <p:nvPr/>
-        </p:nvSpPr>
-        <p:spPr>
-          <a:xfrm>
-            <a:off x="658368" y="228600"/>
-            <a:ext cx="7315200" cy="365760"/>
-          </a:xfrm>
-          <a:prstGeom prst="rect">
-            <a:avLst/>
-          </a:prstGeom>
-          <a:noFill/>
-        </p:spPr>
-        <p:txBody>
-          <a:bodyPr wrap="none">
-            <a:spAutoFit/>
-          </a:bodyPr>
-          <a:lstStyle/>
-          <a:p>
-            <a:r>
-              <a:rPr sz="1300" b="1">
-                <a:solidFill>
-                  <a:srgbClr val="304B35"/>
-                </a:solidFill>
-                <a:latin typeface="Arial"/>
-              </a:rPr>
-              <a:t>POTENTIAL</a:t>
-            </a:r>
-          </a:p>
-        </p:txBody>
-      </p:sp>
-      <p:sp>
-        <p:nvSpPr>
-          <p:cNvPr id="4" name="TextBox 3"/>
-          <p:cNvSpPr txBox="1"/>
-          <p:nvPr/>
-        </p:nvSpPr>
-        <p:spPr>
-          <a:xfrm>
-            <a:off x="640080" y="502920"/>
-            <a:ext cx="10881360" cy="914400"/>
-          </a:xfrm>
-          <a:prstGeom prst="rect">
-            <a:avLst/>
-          </a:prstGeom>
-          <a:noFill/>
-        </p:spPr>
-        <p:txBody>
-          <a:bodyPr wrap="square">
-            <a:spAutoFit/>
-          </a:bodyPr>
-          <a:lstStyle/>
-          <a:p>
-            <a:r>
-              <a:rPr sz="3400" b="1">
-                <a:solidFill>
-                  <a:srgbClr val="20271F"/>
-                </a:solidFill>
-                <a:latin typeface="Georgia"/>
-              </a:rPr>
-              <a:t>A path by capability, not a promise</a:t>
-            </a:r>
-          </a:p>
-        </p:txBody>
-      </p:sp>
-      <p:sp>
-        <p:nvSpPr>
-          <p:cNvPr id="5" name="Rectangle 4"/>
-          <p:cNvSpPr/>
-          <p:nvPr/>
-        </p:nvSpPr>
-        <p:spPr>
-          <a:xfrm>
-            <a:off x="640080" y="1417320"/>
-            <a:ext cx="1280160" cy="50800"/>
-          </a:xfrm>
-          <a:prstGeom prst="rect">
-            <a:avLst/>
-          </a:prstGeom>
-          <a:solidFill>
-            <a:srgbClr val="304B35"/>
-          </a:solidFill>
-          <a:ln>
-            <a:noFill/>
-          </a:ln>
-          <a:effectLst/>
-        </p:spPr>
-        <p:style>
-          <a:lnRef idx="1">
-            <a:schemeClr val="accent1"/>
-          </a:lnRef>
-          <a:fillRef idx="3">
-            <a:schemeClr val="accent1"/>
-          </a:fillRef>
-          <a:effectRef idx="2">
-            <a:schemeClr val="accent1"/>
-          </a:effectRef>
-          <a:fontRef idx="minor">
-            <a:schemeClr val="lt1"/>
-          </a:fontRef>
-        </p:style>
-        <p:txBody>
-          <a:bodyPr rtlCol="0" anchor="ctr"/>
-          <a:lstStyle/>
-          <a:p>
-            <a:pPr algn="ctr"/>
-          </a:p>
-        </p:txBody>
-      </p:sp>
-      <p:sp>
-        <p:nvSpPr>
-          <p:cNvPr id="6" name="TextBox 5"/>
-          <p:cNvSpPr txBox="1"/>
-          <p:nvPr/>
-        </p:nvSpPr>
-        <p:spPr>
-          <a:xfrm>
-            <a:off x="640080" y="6446520"/>
-            <a:ext cx="10881360" cy="320040"/>
-          </a:xfrm>
-          <a:prstGeom prst="rect">
-            <a:avLst/>
-          </a:prstGeom>
-          <a:noFill/>
-        </p:spPr>
-        <p:txBody>
-          <a:bodyPr wrap="none">
-            <a:spAutoFit/>
-          </a:bodyPr>
-          <a:lstStyle/>
-          <a:p>
-            <a:r>
-              <a:rPr sz="1100">
-                <a:solidFill>
-                  <a:srgbClr val="6B7463"/>
-                </a:solidFill>
-                <a:latin typeface="Arial"/>
-              </a:rPr>
-              <a:t>Octro v2.2 — Track 1 Loaded</a:t>
-            </a:r>
-          </a:p>
-        </p:txBody>
-      </p:sp>
-      <p:sp>
-        <p:nvSpPr>
-          <p:cNvPr id="7" name="TextBox 6"/>
-          <p:cNvSpPr txBox="1"/>
-          <p:nvPr/>
-        </p:nvSpPr>
-        <p:spPr>
-          <a:xfrm>
-            <a:off x="685800" y="1920240"/>
-            <a:ext cx="10789920" cy="4389120"/>
-          </a:xfrm>
-          <a:prstGeom prst="rect">
-            <a:avLst/>
-          </a:prstGeom>
-          <a:noFill/>
-        </p:spPr>
-        <p:txBody>
-          <a:bodyPr wrap="square">
-            <a:spAutoFit/>
-          </a:bodyPr>
-          <a:lstStyle/>
-          <a:p>
-            <a:pPr>
-              <a:spcAft>
-                <a:spcPts val="1000"/>
-              </a:spcAft>
-            </a:pPr>
-            <a:r>
-              <a:rPr sz="1900" b="1">
-                <a:solidFill>
-                  <a:srgbClr val="20271F"/>
-                </a:solidFill>
-                <a:latin typeface="Arial"/>
-              </a:rPr>
-              <a:t>▸ Weeks 1-2: stabilize the adapters, test usefulness with individuals and freelancers</a:t>
-            </a:r>
-          </a:p>
-          <a:p>
-            <a:pPr>
-              <a:spcAft>
-                <a:spcPts val="1000"/>
-              </a:spcAft>
-            </a:pPr>
-            <a:r>
-              <a:rPr sz="1900" b="1">
-                <a:solidFill>
-                  <a:srgbClr val="20271F"/>
-                </a:solidFill>
-                <a:latin typeface="Arial"/>
-              </a:rPr>
-              <a:t>▸ Weeks 3-6: authorized connectors, backtests, risk instrumentation</a:t>
-            </a:r>
-          </a:p>
-          <a:p>
-            <a:pPr>
-              <a:spcAft>
-                <a:spcPts val="1000"/>
-              </a:spcAft>
-            </a:pPr>
-            <a:r>
-              <a:rPr sz="1900" b="1">
-                <a:solidFill>
-                  <a:srgbClr val="20271F"/>
-                </a:solidFill>
-                <a:latin typeface="Arial"/>
-              </a:rPr>
-              <a:t>▸ Weeks 7-12: pilot by validated capability and jurisdiction</a:t>
-            </a:r>
-          </a:p>
-          <a:p>
-            <a:pPr>
-              <a:spcAft>
-                <a:spcPts val="1000"/>
-              </a:spcAft>
-            </a:pPr>
-            <a:r>
-              <a:rPr sz="1900" b="1">
-                <a:solidFill>
-                  <a:srgbClr val="20271F"/>
-                </a:solidFill>
-                <a:latin typeface="Arial"/>
-              </a:rPr>
-              <a:t>▸ Proposed business model</a:t>
-            </a:r>
-          </a:p>
-          <a:p>
-            <a:pPr lvl="1">
-              <a:spcAft>
-                <a:spcPts val="400"/>
-              </a:spcAft>
-            </a:pPr>
-            <a:r>
-              <a:rPr sz="1600" b="0">
-                <a:solidFill>
-                  <a:srgbClr val="304B35"/>
-                </a:solidFill>
-                <a:latin typeface="Arial"/>
-              </a:rPr>
-              <a:t>–  Free personal baseline (entry, calendar, simulation); optional subscription for advanced automations; team/API offering</a:t>
-            </a:r>
-          </a:p>
-          <a:p>
-            <a:pPr>
-              <a:spcAft>
-                <a:spcPts val="1000"/>
-              </a:spcAft>
-            </a:pPr>
-            <a:r>
-              <a:rPr sz="1900" b="1">
-                <a:solidFill>
-                  <a:srgbClr val="20271F"/>
-                </a:solidFill>
-                <a:latin typeface="Arial"/>
-              </a:rPr>
-              <a:t>▸ Machine learning, post-hackathon</a:t>
-            </a:r>
-          </a:p>
-          <a:p>
-            <a:pPr lvl="1">
-              <a:spcAft>
-                <a:spcPts val="400"/>
-              </a:spcAft>
-            </a:pPr>
-            <a:r>
-              <a:rPr sz="1600" b="0">
-                <a:solidFill>
-                  <a:srgbClr val="304B35"/>
-                </a:solidFill>
-                <a:latin typeface="Arial"/>
-              </a:rPr>
-              <a:t>–  Estimating delays and defaults from authorized history, train/validation separation, benchmarked against a calendar baseline before being adopted</a:t>
-            </a:r>
-          </a:p>
-          <a:p>
-            <a:pPr>
-              <a:spcAft>
-                <a:spcPts val="1000"/>
-              </a:spcAft>
-            </a:pPr>
-            <a:r>
-              <a:rPr sz="1900" b="1">
-                <a:solidFill>
-                  <a:srgbClr val="20271F"/>
-                </a:solidFill>
-                <a:latin typeface="Arial"/>
-              </a:rPr>
-              <a:t>▸ Sponsorship, DID and connectors advance based on acceptance-test results, never on a promise of global availability</a:t>
-            </a:r>
-          </a:p>
-        </p:txBody>
-      </p:sp>
-    </p:spTree>
-  </p:cSld>
-  <p:clrMapOvr>
-    <a:masterClrMapping/>
-  </p:clrMapOvr>
-</p:sld>
-</file>
-
 <file path=ppt/slides/slide2.xml><?xml version="1.0" encoding="utf-8"?>
 <p:sld xmlns:a="http://schemas.openxmlformats.org/drawingml/2006/main" xmlns:p="http://schemas.openxmlformats.org/presentationml/2006/main" xmlns:r="http://schemas.openxmlformats.org/officeDocument/2006/relationships">
   <p:cSld>
@@ -4624,7 +4261,7 @@
                 </a:solidFill>
                 <a:latin typeface="Georgia"/>
               </a:rPr>
-              <a:t>Algorithms used</a:t>
+              <a:t>Algorithms, agents, MCP, ML</a:t>
             </a:r>
           </a:p>
         </p:txBody>
@@ -4715,8 +4352,8 @@
         </p:nvSpPr>
         <p:spPr>
           <a:xfrm>
-            <a:off x="685800" y="1920240"/>
-            <a:ext cx="10789920" cy="4389120"/>
+            <a:off x="685800" y="1874519"/>
+            <a:ext cx="5394960" cy="365760"/>
           </a:xfrm>
           <a:prstGeom prst="rect">
             <a:avLst/>
@@ -4724,212 +4361,33 @@
           <a:noFill/>
         </p:spPr>
         <p:txBody>
-          <a:bodyPr wrap="square">
+          <a:bodyPr wrap="none">
             <a:spAutoFit/>
           </a:bodyPr>
           <a:lstStyle/>
           <a:p>
-            <a:pPr>
-              <a:spcAft>
-                <a:spcPts val="1000"/>
-              </a:spcAft>
-            </a:pPr>
-            <a:r>
-              <a:rPr sz="2000" b="1">
-                <a:solidFill>
-                  <a:srgbClr val="20271F"/>
+            <a:r>
+              <a:rPr sz="1700" b="1">
+                <a:solidFill>
+                  <a:srgbClr val="304B35"/>
                 </a:solidFill>
                 <a:latin typeface="Arial"/>
               </a:rPr>
-              <a:t>▸ CVaR — closed form (Rockafellar–Uryasev)</a:t>
-            </a:r>
-          </a:p>
-          <a:p>
-            <a:pPr lvl="1">
-              <a:spcAft>
-                <a:spcPts val="400"/>
-              </a:spcAft>
-            </a:pPr>
-            <a:r>
-              <a:rPr sz="1600" b="0">
-                <a:solidFill>
-                  <a:srgbClr val="304B35"/>
-                </a:solidFill>
-                <a:latin typeface="Arial"/>
-              </a:rPr>
-              <a:t>–  Verified against the CDC fixture: losses [0,0,100], weights [0.80, 0.15, 0.05] → CVaR95 = 100</a:t>
-            </a:r>
-          </a:p>
-          <a:p>
-            <a:pPr>
-              <a:spcAft>
-                <a:spcPts val="1000"/>
-              </a:spcAft>
-            </a:pPr>
-            <a:r>
-              <a:rPr sz="2000" b="1">
-                <a:solidFill>
-                  <a:srgbClr val="20271F"/>
-                </a:solidFill>
-                <a:latin typeface="Arial"/>
-              </a:rPr>
-              <a:t>▸ Personal no-debt engine</a:t>
-            </a:r>
-          </a:p>
-          <a:p>
-            <a:pPr lvl="1">
-              <a:spcAft>
-                <a:spcPts val="400"/>
-              </a:spcAft>
-            </a:pPr>
-            <a:r>
-              <a:rPr sz="1600" b="0">
-                <a:solidFill>
-                  <a:srgbClr val="304B35"/>
-                </a:solidFill>
-                <a:latin typeface="Arial"/>
-              </a:rPr>
-              <a:t>–  Protected reserve as a hard constraint, never auto-relaxed; amount re-checked after rounding</a:t>
-            </a:r>
-          </a:p>
-          <a:p>
-            <a:pPr>
-              <a:spcAft>
-                <a:spcPts val="1000"/>
-              </a:spcAft>
-            </a:pPr>
-            <a:r>
-              <a:rPr sz="2000" b="1">
-                <a:solidFill>
-                  <a:srgbClr val="20271F"/>
-                </a:solidFill>
-                <a:latin typeface="Arial"/>
-              </a:rPr>
-              <a:t>▸ Financing allocation</a:t>
-            </a:r>
-          </a:p>
-          <a:p>
-            <a:pPr lvl="1">
-              <a:spcAft>
-                <a:spcPts val="400"/>
-              </a:spcAft>
-            </a:pPr>
-            <a:r>
-              <a:rPr sz="1600" b="0">
-                <a:solidFill>
-                  <a:srgbClr val="304B35"/>
-                </a:solidFill>
-                <a:latin typeface="Arial"/>
-              </a:rPr>
-              <a:t>–  Cheapest offer first (greedy), terminal debt kept past the horizon</a:t>
-            </a:r>
-          </a:p>
-          <a:p>
-            <a:pPr>
-              <a:spcAft>
-                <a:spcPts val="1000"/>
-              </a:spcAft>
-            </a:pPr>
-            <a:r>
-              <a:rPr sz="2000" b="1">
-                <a:solidFill>
-                  <a:srgbClr val="20271F"/>
-                </a:solidFill>
-                <a:latin typeface="Arial"/>
-              </a:rPr>
-              <a:t>▸ No unified LP/MILP solver yet (scipy/HiGHS)</a:t>
-            </a:r>
-          </a:p>
-          <a:p>
-            <a:pPr lvl="1">
-              <a:spcAft>
-                <a:spcPts val="400"/>
-              </a:spcAft>
-            </a:pPr>
-            <a:r>
-              <a:rPr sz="1600" b="0">
-                <a:solidFill>
-                  <a:srgbClr val="304B35"/>
-                </a:solidFill>
-                <a:latin typeface="Arial"/>
-              </a:rPr>
-              <a:t>–  Every CDC guarantee is proven on the demo scenarios, not on a combined multi-asset plan</a:t>
-            </a:r>
-          </a:p>
-        </p:txBody>
-      </p:sp>
-    </p:spTree>
-  </p:cSld>
-  <p:clrMapOvr>
-    <a:masterClrMapping/>
-  </p:clrMapOvr>
-</p:sld>
-</file>
-
-<file path=ppt/slides/slide7.xml><?xml version="1.0" encoding="utf-8"?>
-<p:sld xmlns:a="http://schemas.openxmlformats.org/drawingml/2006/main" xmlns:p="http://schemas.openxmlformats.org/presentationml/2006/main" xmlns:r="http://schemas.openxmlformats.org/officeDocument/2006/relationships">
-  <p:cSld>
-    <p:spTree>
-      <p:nvGrpSpPr>
-        <p:cNvPr id="1" name=""/>
-        <p:cNvGrpSpPr/>
-        <p:nvPr/>
-      </p:nvGrpSpPr>
-      <p:grpSpPr/>
-      <p:sp>
-        <p:nvSpPr>
-          <p:cNvPr id="2" name="Rectangle 1"/>
-          <p:cNvSpPr/>
-          <p:nvPr/>
-        </p:nvSpPr>
-        <p:spPr>
-          <a:xfrm>
-            <a:off x="0" y="0"/>
-            <a:ext cx="12191695" cy="6858000"/>
-          </a:xfrm>
-          <a:prstGeom prst="rect">
-            <a:avLst/>
-          </a:prstGeom>
-          <a:solidFill>
-            <a:srgbClr val="F5F2E8"/>
-          </a:solidFill>
-          <a:ln>
-            <a:noFill/>
-          </a:ln>
-          <a:effectLst/>
-        </p:spPr>
-        <p:style>
-          <a:lnRef idx="1">
-            <a:schemeClr val="accent1"/>
-          </a:lnRef>
-          <a:fillRef idx="3">
-            <a:schemeClr val="accent1"/>
-          </a:fillRef>
-          <a:effectRef idx="2">
-            <a:schemeClr val="accent1"/>
-          </a:effectRef>
-          <a:fontRef idx="minor">
-            <a:schemeClr val="lt1"/>
-          </a:fontRef>
-        </p:style>
-        <p:txBody>
-          <a:bodyPr rtlCol="0" anchor="ctr"/>
-          <a:lstStyle/>
-          <a:p>
-            <a:pPr algn="ctr"/>
-          </a:p>
-        </p:txBody>
-      </p:sp>
-      <p:sp>
-        <p:nvSpPr>
-          <p:cNvPr id="3" name="TextBox 2"/>
+              <a:t>Algorithms used</a:t>
+            </a:r>
+          </a:p>
+        </p:txBody>
+      </p:sp>
+      <p:sp>
+        <p:nvSpPr>
+          <p:cNvPr id="8" name="TextBox 7"/>
           <p:cNvSpPr txBox="1"/>
           <p:nvPr/>
         </p:nvSpPr>
         <p:spPr>
           <a:xfrm>
-            <a:off x="658368" y="228600"/>
-            <a:ext cx="7315200" cy="365760"/>
+            <a:off x="685800" y="2258567"/>
+            <a:ext cx="5394960" cy="1764792"/>
           </a:xfrm>
           <a:prstGeom prst="rect">
             <a:avLst/>
@@ -4937,33 +4395,70 @@
           <a:noFill/>
         </p:spPr>
         <p:txBody>
-          <a:bodyPr wrap="none">
+          <a:bodyPr wrap="square">
             <a:spAutoFit/>
           </a:bodyPr>
           <a:lstStyle/>
           <a:p>
-            <a:r>
-              <a:rPr sz="1300" b="1">
-                <a:solidFill>
-                  <a:srgbClr val="304B35"/>
+            <a:pPr>
+              <a:spcAft>
+                <a:spcPts val="600"/>
+              </a:spcAft>
+            </a:pPr>
+            <a:r>
+              <a:rPr sz="1350">
+                <a:solidFill>
+                  <a:srgbClr val="20271F"/>
                 </a:solidFill>
                 <a:latin typeface="Arial"/>
               </a:rPr>
-              <a:t>DEVELOPER FEEDBACK</a:t>
-            </a:r>
-          </a:p>
-        </p:txBody>
-      </p:sp>
-      <p:sp>
-        <p:nvSpPr>
-          <p:cNvPr id="4" name="TextBox 3"/>
+              <a:t>▸ CVaR closed form (Rockafellar–Uryasev), verified on the CDC fixture → CVaR95 = 100</a:t>
+            </a:r>
+          </a:p>
+          <a:p>
+            <a:pPr>
+              <a:spcAft>
+                <a:spcPts val="600"/>
+              </a:spcAft>
+            </a:pPr>
+            <a:r>
+              <a:rPr sz="1350">
+                <a:solidFill>
+                  <a:srgbClr val="20271F"/>
+                </a:solidFill>
+                <a:latin typeface="Arial"/>
+              </a:rPr>
+              <a:t>▸ No-debt engine: protected reserve as a hard constraint; financing picks cheapest offer first</a:t>
+            </a:r>
+          </a:p>
+          <a:p>
+            <a:pPr>
+              <a:spcAft>
+                <a:spcPts val="600"/>
+              </a:spcAft>
+            </a:pPr>
+            <a:r>
+              <a:rPr sz="1350">
+                <a:solidFill>
+                  <a:srgbClr val="20271F"/>
+                </a:solidFill>
+                <a:latin typeface="Arial"/>
+              </a:rPr>
+              <a:t>▸ No unified LP/MILP solver yet (scipy/HiGHS)</a:t>
+            </a:r>
+          </a:p>
+        </p:txBody>
+      </p:sp>
+      <p:sp>
+        <p:nvSpPr>
+          <p:cNvPr id="9" name="TextBox 8"/>
           <p:cNvSpPr txBox="1"/>
           <p:nvPr/>
         </p:nvSpPr>
         <p:spPr>
           <a:xfrm>
-            <a:off x="640080" y="502920"/>
-            <a:ext cx="10881360" cy="914400"/>
+            <a:off x="6263640" y="1874519"/>
+            <a:ext cx="5394960" cy="365760"/>
           </a:xfrm>
           <a:prstGeom prst="rect">
             <a:avLst/>
@@ -4971,17 +4466,17 @@
           <a:noFill/>
         </p:spPr>
         <p:txBody>
-          <a:bodyPr wrap="square">
+          <a:bodyPr wrap="none">
             <a:spAutoFit/>
           </a:bodyPr>
           <a:lstStyle/>
           <a:p>
             <a:r>
-              <a:rPr sz="3400" b="1">
-                <a:solidFill>
-                  <a:srgbClr val="20271F"/>
-                </a:solidFill>
-                <a:latin typeface="Georgia"/>
+              <a:rPr sz="1700" b="1">
+                <a:solidFill>
+                  <a:srgbClr val="304B35"/>
+                </a:solidFill>
+                <a:latin typeface="Arial"/>
               </a:rPr>
               <a:t>Agentic orchestration</a:t>
             </a:r>
@@ -4990,58 +4485,14 @@
       </p:sp>
       <p:sp>
         <p:nvSpPr>
-          <p:cNvPr id="5" name="Rectangle 4"/>
-          <p:cNvSpPr/>
-          <p:nvPr/>
-        </p:nvSpPr>
-        <p:spPr>
-          <a:xfrm>
-            <a:off x="640080" y="1417320"/>
-            <a:ext cx="1280160" cy="50800"/>
-          </a:xfrm>
-          <a:prstGeom prst="rect">
-            <a:avLst/>
-          </a:prstGeom>
-          <a:solidFill>
-            <a:srgbClr val="304B35"/>
-          </a:solidFill>
-          <a:ln>
-            <a:noFill/>
-          </a:ln>
-          <a:effectLst/>
-        </p:spPr>
-        <p:style>
-          <a:lnRef idx="1">
-            <a:schemeClr val="accent1"/>
-          </a:lnRef>
-          <a:fillRef idx="3">
-            <a:schemeClr val="accent1"/>
-          </a:fillRef>
-          <a:effectRef idx="2">
-            <a:schemeClr val="accent1"/>
-          </a:effectRef>
-          <a:fontRef idx="minor">
-            <a:schemeClr val="lt1"/>
-          </a:fontRef>
-        </p:style>
-        <p:txBody>
-          <a:bodyPr rtlCol="0" anchor="ctr"/>
-          <a:lstStyle/>
-          <a:p>
-            <a:pPr algn="ctr"/>
-          </a:p>
-        </p:txBody>
-      </p:sp>
-      <p:sp>
-        <p:nvSpPr>
-          <p:cNvPr id="6" name="TextBox 5"/>
+          <p:cNvPr id="10" name="TextBox 9"/>
           <p:cNvSpPr txBox="1"/>
           <p:nvPr/>
         </p:nvSpPr>
         <p:spPr>
           <a:xfrm>
-            <a:off x="640080" y="6446520"/>
-            <a:ext cx="10881360" cy="320040"/>
+            <a:off x="6263640" y="2258567"/>
+            <a:ext cx="5394960" cy="1764792"/>
           </a:xfrm>
           <a:prstGeom prst="rect">
             <a:avLst/>
@@ -5049,33 +4500,70 @@
           <a:noFill/>
         </p:spPr>
         <p:txBody>
-          <a:bodyPr wrap="none">
+          <a:bodyPr wrap="square">
             <a:spAutoFit/>
           </a:bodyPr>
           <a:lstStyle/>
           <a:p>
-            <a:r>
-              <a:rPr sz="1100">
-                <a:solidFill>
-                  <a:srgbClr val="6B7463"/>
+            <a:pPr>
+              <a:spcAft>
+                <a:spcPts val="600"/>
+              </a:spcAft>
+            </a:pPr>
+            <a:r>
+              <a:rPr sz="1350">
+                <a:solidFill>
+                  <a:srgbClr val="20271F"/>
                 </a:solidFill>
                 <a:latin typeface="Arial"/>
               </a:rPr>
-              <a:t>Octro v2.2 — Track 1 Loaded</a:t>
-            </a:r>
-          </a:p>
-        </p:txBody>
-      </p:sp>
-      <p:sp>
-        <p:nvSpPr>
-          <p:cNvPr id="7" name="TextBox 6"/>
+              <a:t>▸ Bounded coordinator, 12 tool calls max (AGT-01)</a:t>
+            </a:r>
+          </a:p>
+          <a:p>
+            <a:pPr>
+              <a:spcAft>
+                <a:spcPts val="600"/>
+              </a:spcAft>
+            </a:pPr>
+            <a:r>
+              <a:rPr sz="1350">
+                <a:solidFill>
+                  <a:srgbClr val="20271F"/>
+                </a:solidFill>
+                <a:latin typeface="Arial"/>
+              </a:rPr>
+              <a:t>▸ No signing or submission tool reachable by the LLM (AGT-02)</a:t>
+            </a:r>
+          </a:p>
+          <a:p>
+            <a:pPr>
+              <a:spcAft>
+                <a:spcPts val="600"/>
+              </a:spcAft>
+            </a:pPr>
+            <a:r>
+              <a:rPr sz="1350">
+                <a:solidFill>
+                  <a:srgbClr val="20271F"/>
+                </a:solidFill>
+                <a:latin typeface="Arial"/>
+              </a:rPr>
+              <a:t>▸ Currently a 2-call shortcut, not the CDC's full 6-stage graph</a:t>
+            </a:r>
+          </a:p>
+        </p:txBody>
+      </p:sp>
+      <p:sp>
+        <p:nvSpPr>
+          <p:cNvPr id="11" name="TextBox 10"/>
           <p:cNvSpPr txBox="1"/>
           <p:nvPr/>
         </p:nvSpPr>
         <p:spPr>
           <a:xfrm>
-            <a:off x="685800" y="1920240"/>
-            <a:ext cx="10789920" cy="4389120"/>
+            <a:off x="685800" y="4160520"/>
+            <a:ext cx="5394960" cy="365760"/>
           </a:xfrm>
           <a:prstGeom prst="rect">
             <a:avLst/>
@@ -5083,164 +4571,33 @@
           <a:noFill/>
         </p:spPr>
         <p:txBody>
-          <a:bodyPr wrap="square">
+          <a:bodyPr wrap="none">
             <a:spAutoFit/>
           </a:bodyPr>
           <a:lstStyle/>
           <a:p>
-            <a:pPr>
-              <a:spcAft>
-                <a:spcPts val="1000"/>
-              </a:spcAft>
-            </a:pPr>
-            <a:r>
-              <a:rPr sz="2000" b="1">
-                <a:solidFill>
-                  <a:srgbClr val="20271F"/>
+            <a:r>
+              <a:rPr sz="1700" b="1">
+                <a:solidFill>
+                  <a:srgbClr val="304B35"/>
                 </a:solidFill>
                 <a:latin typeface="Arial"/>
               </a:rPr>
-              <a:t>▸ Bounded coordinator: 12 tool calls maximum (AGT-01)</a:t>
-            </a:r>
-          </a:p>
-          <a:p>
-            <a:pPr>
-              <a:spcAft>
-                <a:spcPts val="1000"/>
-              </a:spcAft>
-            </a:pPr>
-            <a:r>
-              <a:rPr sz="2000" b="1">
-                <a:solidFill>
-                  <a:srgbClr val="20271F"/>
-                </a:solidFill>
-                <a:latin typeface="Arial"/>
-              </a:rPr>
-              <a:t>▸ No signing or submission tool ever reachable by the LLM (AGT-02)</a:t>
-            </a:r>
-          </a:p>
-          <a:p>
-            <a:pPr>
-              <a:spcAft>
-                <a:spcPts val="1000"/>
-              </a:spcAft>
-            </a:pPr>
-            <a:r>
-              <a:rPr sz="2000" b="1">
-                <a:solidFill>
-                  <a:srgbClr val="20271F"/>
-                </a:solidFill>
-                <a:latin typeface="Arial"/>
-              </a:rPr>
-              <a:t>▸ Deterministic fallback if the LLM provider is unavailable (AGT-03)</a:t>
-            </a:r>
-          </a:p>
-          <a:p>
-            <a:pPr>
-              <a:spcAft>
-                <a:spcPts val="1000"/>
-              </a:spcAft>
-            </a:pPr>
-            <a:r>
-              <a:rPr sz="2000" b="1">
-                <a:solidFill>
-                  <a:srgbClr val="20271F"/>
-                </a:solidFill>
-                <a:latin typeface="Arial"/>
-              </a:rPr>
-              <a:t>▸ Current implementation: a 2-call shortcut (analyze + explain)</a:t>
-            </a:r>
-          </a:p>
-          <a:p>
-            <a:pPr lvl="1">
-              <a:spcAft>
-                <a:spcPts val="400"/>
-              </a:spcAft>
-            </a:pPr>
-            <a:r>
-              <a:rPr sz="1600" b="0">
-                <a:solidFill>
-                  <a:srgbClr val="304B35"/>
-                </a:solidFill>
-                <a:latin typeface="Arial"/>
-              </a:rPr>
-              <a:t>–  Not yet the CDC's full 6-stage graph: collect → analyze → simulate → explain → await decision → follow up</a:t>
-            </a:r>
-          </a:p>
-        </p:txBody>
-      </p:sp>
-    </p:spTree>
-  </p:cSld>
-  <p:clrMapOvr>
-    <a:masterClrMapping/>
-  </p:clrMapOvr>
-</p:sld>
-</file>
-
-<file path=ppt/slides/slide8.xml><?xml version="1.0" encoding="utf-8"?>
-<p:sld xmlns:a="http://schemas.openxmlformats.org/drawingml/2006/main" xmlns:p="http://schemas.openxmlformats.org/presentationml/2006/main" xmlns:r="http://schemas.openxmlformats.org/officeDocument/2006/relationships">
-  <p:cSld>
-    <p:spTree>
-      <p:nvGrpSpPr>
-        <p:cNvPr id="1" name=""/>
-        <p:cNvGrpSpPr/>
-        <p:nvPr/>
-      </p:nvGrpSpPr>
-      <p:grpSpPr/>
-      <p:sp>
-        <p:nvSpPr>
-          <p:cNvPr id="2" name="Rectangle 1"/>
-          <p:cNvSpPr/>
-          <p:nvPr/>
-        </p:nvSpPr>
-        <p:spPr>
-          <a:xfrm>
-            <a:off x="0" y="0"/>
-            <a:ext cx="12191695" cy="6858000"/>
-          </a:xfrm>
-          <a:prstGeom prst="rect">
-            <a:avLst/>
-          </a:prstGeom>
-          <a:solidFill>
-            <a:srgbClr val="F5F2E8"/>
-          </a:solidFill>
-          <a:ln>
-            <a:noFill/>
-          </a:ln>
-          <a:effectLst/>
-        </p:spPr>
-        <p:style>
-          <a:lnRef idx="1">
-            <a:schemeClr val="accent1"/>
-          </a:lnRef>
-          <a:fillRef idx="3">
-            <a:schemeClr val="accent1"/>
-          </a:fillRef>
-          <a:effectRef idx="2">
-            <a:schemeClr val="accent1"/>
-          </a:effectRef>
-          <a:fontRef idx="minor">
-            <a:schemeClr val="lt1"/>
-          </a:fontRef>
-        </p:style>
-        <p:txBody>
-          <a:bodyPr rtlCol="0" anchor="ctr"/>
-          <a:lstStyle/>
-          <a:p>
-            <a:pPr algn="ctr"/>
-          </a:p>
-        </p:txBody>
-      </p:sp>
-      <p:sp>
-        <p:nvSpPr>
-          <p:cNvPr id="3" name="TextBox 2"/>
+              <a:t>MCP</a:t>
+            </a:r>
+          </a:p>
+        </p:txBody>
+      </p:sp>
+      <p:sp>
+        <p:nvSpPr>
+          <p:cNvPr id="12" name="TextBox 11"/>
           <p:cNvSpPr txBox="1"/>
           <p:nvPr/>
         </p:nvSpPr>
         <p:spPr>
           <a:xfrm>
-            <a:off x="658368" y="228600"/>
-            <a:ext cx="7315200" cy="365760"/>
+            <a:off x="685800" y="4544568"/>
+            <a:ext cx="5394960" cy="1764792"/>
           </a:xfrm>
           <a:prstGeom prst="rect">
             <a:avLst/>
@@ -5248,33 +4605,70 @@
           <a:noFill/>
         </p:spPr>
         <p:txBody>
-          <a:bodyPr wrap="none">
+          <a:bodyPr wrap="square">
             <a:spAutoFit/>
           </a:bodyPr>
           <a:lstStyle/>
           <a:p>
-            <a:r>
-              <a:rPr sz="1300" b="1">
-                <a:solidFill>
-                  <a:srgbClr val="304B35"/>
+            <a:pPr>
+              <a:spcAft>
+                <a:spcPts val="600"/>
+              </a:spcAft>
+            </a:pPr>
+            <a:r>
+              <a:rPr sz="1350">
+                <a:solidFill>
+                  <a:srgbClr val="20271F"/>
                 </a:solidFill>
                 <a:latin typeface="Arial"/>
               </a:rPr>
-              <a:t>DEVELOPER FEEDBACK</a:t>
-            </a:r>
-          </a:p>
-        </p:txBody>
-      </p:sp>
-      <p:sp>
-        <p:nvSpPr>
-          <p:cNvPr id="4" name="TextBox 3"/>
+              <a:t>▸ 3 tools exposed, strictly read-only</a:t>
+            </a:r>
+          </a:p>
+          <a:p>
+            <a:pPr>
+              <a:spcAft>
+                <a:spcPts val="600"/>
+              </a:spcAft>
+            </a:pPr>
+            <a:r>
+              <a:rPr sz="1350">
+                <a:solidFill>
+                  <a:srgbClr val="20271F"/>
+                </a:solidFill>
+                <a:latin typeface="Arial"/>
+              </a:rPr>
+              <a:t>▸ Signing and submission always outside the LLM and outside MCP</a:t>
+            </a:r>
+          </a:p>
+          <a:p>
+            <a:pPr>
+              <a:spcAft>
+                <a:spcPts val="600"/>
+              </a:spcAft>
+            </a:pPr>
+            <a:r>
+              <a:rPr sz="1350">
+                <a:solidFill>
+                  <a:srgbClr val="20271F"/>
+                </a:solidFill>
+                <a:latin typeface="Arial"/>
+              </a:rPr>
+              <a:t>▸ Responses currently hardcoded on the Lina fixture</a:t>
+            </a:r>
+          </a:p>
+        </p:txBody>
+      </p:sp>
+      <p:sp>
+        <p:nvSpPr>
+          <p:cNvPr id="13" name="TextBox 12"/>
           <p:cNvSpPr txBox="1"/>
           <p:nvPr/>
         </p:nvSpPr>
         <p:spPr>
           <a:xfrm>
-            <a:off x="640080" y="502920"/>
-            <a:ext cx="10881360" cy="914400"/>
+            <a:off x="6263640" y="4160520"/>
+            <a:ext cx="5394960" cy="365760"/>
           </a:xfrm>
           <a:prstGeom prst="rect">
             <a:avLst/>
@@ -5282,77 +4676,33 @@
           <a:noFill/>
         </p:spPr>
         <p:txBody>
-          <a:bodyPr wrap="square">
+          <a:bodyPr wrap="none">
             <a:spAutoFit/>
           </a:bodyPr>
           <a:lstStyle/>
           <a:p>
             <a:r>
-              <a:rPr sz="3400" b="1">
-                <a:solidFill>
-                  <a:srgbClr val="20271F"/>
-                </a:solidFill>
-                <a:latin typeface="Georgia"/>
+              <a:rPr sz="1700" b="1">
+                <a:solidFill>
+                  <a:srgbClr val="304B35"/>
+                </a:solidFill>
+                <a:latin typeface="Arial"/>
               </a:rPr>
-              <a:t>MCP (Model Context Protocol)</a:t>
-            </a:r>
-          </a:p>
-        </p:txBody>
-      </p:sp>
-      <p:sp>
-        <p:nvSpPr>
-          <p:cNvPr id="5" name="Rectangle 4"/>
-          <p:cNvSpPr/>
-          <p:nvPr/>
-        </p:nvSpPr>
-        <p:spPr>
-          <a:xfrm>
-            <a:off x="640080" y="1417320"/>
-            <a:ext cx="1280160" cy="50800"/>
-          </a:xfrm>
-          <a:prstGeom prst="rect">
-            <a:avLst/>
-          </a:prstGeom>
-          <a:solidFill>
-            <a:srgbClr val="304B35"/>
-          </a:solidFill>
-          <a:ln>
-            <a:noFill/>
-          </a:ln>
-          <a:effectLst/>
-        </p:spPr>
-        <p:style>
-          <a:lnRef idx="1">
-            <a:schemeClr val="accent1"/>
-          </a:lnRef>
-          <a:fillRef idx="3">
-            <a:schemeClr val="accent1"/>
-          </a:fillRef>
-          <a:effectRef idx="2">
-            <a:schemeClr val="accent1"/>
-          </a:effectRef>
-          <a:fontRef idx="minor">
-            <a:schemeClr val="lt1"/>
-          </a:fontRef>
-        </p:style>
-        <p:txBody>
-          <a:bodyPr rtlCol="0" anchor="ctr"/>
-          <a:lstStyle/>
-          <a:p>
-            <a:pPr algn="ctr"/>
-          </a:p>
-        </p:txBody>
-      </p:sp>
-      <p:sp>
-        <p:nvSpPr>
-          <p:cNvPr id="6" name="TextBox 5"/>
+              <a:t>Machine learning</a:t>
+            </a:r>
+          </a:p>
+        </p:txBody>
+      </p:sp>
+      <p:sp>
+        <p:nvSpPr>
+          <p:cNvPr id="14" name="TextBox 13"/>
           <p:cNvSpPr txBox="1"/>
           <p:nvPr/>
         </p:nvSpPr>
         <p:spPr>
           <a:xfrm>
-            <a:off x="640080" y="6446520"/>
-            <a:ext cx="10881360" cy="320040"/>
+            <a:off x="6263640" y="4544568"/>
+            <a:ext cx="5394960" cy="1764792"/>
           </a:xfrm>
           <a:prstGeom prst="rect">
             <a:avLst/>
@@ -5360,40 +4710,6 @@
           <a:noFill/>
         </p:spPr>
         <p:txBody>
-          <a:bodyPr wrap="none">
-            <a:spAutoFit/>
-          </a:bodyPr>
-          <a:lstStyle/>
-          <a:p>
-            <a:r>
-              <a:rPr sz="1100">
-                <a:solidFill>
-                  <a:srgbClr val="6B7463"/>
-                </a:solidFill>
-                <a:latin typeface="Arial"/>
-              </a:rPr>
-              <a:t>Octro v2.2 — Track 1 Loaded</a:t>
-            </a:r>
-          </a:p>
-        </p:txBody>
-      </p:sp>
-      <p:sp>
-        <p:nvSpPr>
-          <p:cNvPr id="7" name="TextBox 6"/>
-          <p:cNvSpPr txBox="1"/>
-          <p:nvPr/>
-        </p:nvSpPr>
-        <p:spPr>
-          <a:xfrm>
-            <a:off x="685800" y="1920240"/>
-            <a:ext cx="10789920" cy="4389120"/>
-          </a:xfrm>
-          <a:prstGeom prst="rect">
-            <a:avLst/>
-          </a:prstGeom>
-          <a:noFill/>
-        </p:spPr>
-        <p:txBody>
           <a:bodyPr wrap="square">
             <a:spAutoFit/>
           </a:bodyPr>
@@ -5401,354 +4717,11 @@
           <a:p>
             <a:pPr>
               <a:spcAft>
-                <a:spcPts val="1000"/>
+                <a:spcPts val="600"/>
               </a:spcAft>
             </a:pPr>
             <a:r>
-              <a:rPr sz="2000" b="1">
-                <a:solidFill>
-                  <a:srgbClr val="20271F"/>
-                </a:solidFill>
-                <a:latin typeface="Arial"/>
-              </a:rPr>
-              <a:t>▸ 3 tools exposed, strictly read-only</a:t>
-            </a:r>
-          </a:p>
-          <a:p>
-            <a:pPr lvl="1">
-              <a:spcAft>
-                <a:spcPts val="400"/>
-              </a:spcAft>
-            </a:pPr>
-            <a:r>
-              <a:rPr sz="1600" b="0">
-                <a:solidFill>
-                  <a:srgbClr val="304B35"/>
-                </a:solidFill>
-                <a:latin typeface="Arial"/>
-              </a:rPr>
-              <a:t>–  Account summary, cash-flow projection, proposal explanation</a:t>
-            </a:r>
-          </a:p>
-          <a:p>
-            <a:pPr>
-              <a:spcAft>
-                <a:spcPts val="1000"/>
-              </a:spcAft>
-            </a:pPr>
-            <a:r>
-              <a:rPr sz="2000" b="1">
-                <a:solidFill>
-                  <a:srgbClr val="20271F"/>
-                </a:solidFill>
-                <a:latin typeface="Arial"/>
-              </a:rPr>
-              <a:t>▸ Authorization inherited from the business API (tenant, scope, token)</a:t>
-            </a:r>
-          </a:p>
-          <a:p>
-            <a:pPr lvl="1">
-              <a:spcAft>
-                <a:spcPts val="400"/>
-              </a:spcAft>
-            </a:pPr>
-            <a:r>
-              <a:rPr sz="1600" b="0">
-                <a:solidFill>
-                  <a:srgbClr val="304B35"/>
-                </a:solidFill>
-                <a:latin typeface="Arial"/>
-              </a:rPr>
-              <a:t>–  MCP is not a second authorization path, nor proof of trust on its own</a:t>
-            </a:r>
-          </a:p>
-          <a:p>
-            <a:pPr>
-              <a:spcAft>
-                <a:spcPts val="1000"/>
-              </a:spcAft>
-            </a:pPr>
-            <a:r>
-              <a:rPr sz="2000" b="1">
-                <a:solidFill>
-                  <a:srgbClr val="20271F"/>
-                </a:solidFill>
-                <a:latin typeface="Arial"/>
-              </a:rPr>
-              <a:t>▸ XRPL signing and submission: always outside the LLM and outside MCP</a:t>
-            </a:r>
-          </a:p>
-          <a:p>
-            <a:pPr>
-              <a:spcAft>
-                <a:spcPts val="1000"/>
-              </a:spcAft>
-            </a:pPr>
-            <a:r>
-              <a:rPr sz="2000" b="1">
-                <a:solidFill>
-                  <a:srgbClr val="20271F"/>
-                </a:solidFill>
-                <a:latin typeface="Arial"/>
-              </a:rPr>
-              <a:t>▸ Current limitation: responses are hardcoded on the Lina fixture</a:t>
-            </a:r>
-          </a:p>
-          <a:p>
-            <a:pPr lvl="1">
-              <a:spcAft>
-                <a:spcPts val="400"/>
-              </a:spcAft>
-            </a:pPr>
-            <a:r>
-              <a:rPr sz="1600" b="0">
-                <a:solidFill>
-                  <a:srgbClr val="304B35"/>
-                </a:solidFill>
-                <a:latin typeface="Arial"/>
-              </a:rPr>
-              <a:t>–  Not yet wired to real use cases or to the CDC's data.*/engine.* namespaces</a:t>
-            </a:r>
-          </a:p>
-        </p:txBody>
-      </p:sp>
-    </p:spTree>
-  </p:cSld>
-  <p:clrMapOvr>
-    <a:masterClrMapping/>
-  </p:clrMapOvr>
-</p:sld>
-</file>
-
-<file path=ppt/slides/slide9.xml><?xml version="1.0" encoding="utf-8"?>
-<p:sld xmlns:a="http://schemas.openxmlformats.org/drawingml/2006/main" xmlns:p="http://schemas.openxmlformats.org/presentationml/2006/main" xmlns:r="http://schemas.openxmlformats.org/officeDocument/2006/relationships">
-  <p:cSld>
-    <p:spTree>
-      <p:nvGrpSpPr>
-        <p:cNvPr id="1" name=""/>
-        <p:cNvGrpSpPr/>
-        <p:nvPr/>
-      </p:nvGrpSpPr>
-      <p:grpSpPr/>
-      <p:sp>
-        <p:nvSpPr>
-          <p:cNvPr id="2" name="Rectangle 1"/>
-          <p:cNvSpPr/>
-          <p:nvPr/>
-        </p:nvSpPr>
-        <p:spPr>
-          <a:xfrm>
-            <a:off x="0" y="0"/>
-            <a:ext cx="12191695" cy="6858000"/>
-          </a:xfrm>
-          <a:prstGeom prst="rect">
-            <a:avLst/>
-          </a:prstGeom>
-          <a:solidFill>
-            <a:srgbClr val="F5F2E8"/>
-          </a:solidFill>
-          <a:ln>
-            <a:noFill/>
-          </a:ln>
-          <a:effectLst/>
-        </p:spPr>
-        <p:style>
-          <a:lnRef idx="1">
-            <a:schemeClr val="accent1"/>
-          </a:lnRef>
-          <a:fillRef idx="3">
-            <a:schemeClr val="accent1"/>
-          </a:fillRef>
-          <a:effectRef idx="2">
-            <a:schemeClr val="accent1"/>
-          </a:effectRef>
-          <a:fontRef idx="minor">
-            <a:schemeClr val="lt1"/>
-          </a:fontRef>
-        </p:style>
-        <p:txBody>
-          <a:bodyPr rtlCol="0" anchor="ctr"/>
-          <a:lstStyle/>
-          <a:p>
-            <a:pPr algn="ctr"/>
-          </a:p>
-        </p:txBody>
-      </p:sp>
-      <p:sp>
-        <p:nvSpPr>
-          <p:cNvPr id="3" name="TextBox 2"/>
-          <p:cNvSpPr txBox="1"/>
-          <p:nvPr/>
-        </p:nvSpPr>
-        <p:spPr>
-          <a:xfrm>
-            <a:off x="658368" y="228600"/>
-            <a:ext cx="7315200" cy="365760"/>
-          </a:xfrm>
-          <a:prstGeom prst="rect">
-            <a:avLst/>
-          </a:prstGeom>
-          <a:noFill/>
-        </p:spPr>
-        <p:txBody>
-          <a:bodyPr wrap="none">
-            <a:spAutoFit/>
-          </a:bodyPr>
-          <a:lstStyle/>
-          <a:p>
-            <a:r>
-              <a:rPr sz="1300" b="1">
-                <a:solidFill>
-                  <a:srgbClr val="304B35"/>
-                </a:solidFill>
-                <a:latin typeface="Arial"/>
-              </a:rPr>
-              <a:t>DEVELOPER FEEDBACK</a:t>
-            </a:r>
-          </a:p>
-        </p:txBody>
-      </p:sp>
-      <p:sp>
-        <p:nvSpPr>
-          <p:cNvPr id="4" name="TextBox 3"/>
-          <p:cNvSpPr txBox="1"/>
-          <p:nvPr/>
-        </p:nvSpPr>
-        <p:spPr>
-          <a:xfrm>
-            <a:off x="640080" y="502920"/>
-            <a:ext cx="10881360" cy="914400"/>
-          </a:xfrm>
-          <a:prstGeom prst="rect">
-            <a:avLst/>
-          </a:prstGeom>
-          <a:noFill/>
-        </p:spPr>
-        <p:txBody>
-          <a:bodyPr wrap="square">
-            <a:spAutoFit/>
-          </a:bodyPr>
-          <a:lstStyle/>
-          <a:p>
-            <a:r>
-              <a:rPr sz="3400" b="1">
-                <a:solidFill>
-                  <a:srgbClr val="20271F"/>
-                </a:solidFill>
-                <a:latin typeface="Georgia"/>
-              </a:rPr>
-              <a:t>Machine learning</a:t>
-            </a:r>
-          </a:p>
-        </p:txBody>
-      </p:sp>
-      <p:sp>
-        <p:nvSpPr>
-          <p:cNvPr id="5" name="Rectangle 4"/>
-          <p:cNvSpPr/>
-          <p:nvPr/>
-        </p:nvSpPr>
-        <p:spPr>
-          <a:xfrm>
-            <a:off x="640080" y="1417320"/>
-            <a:ext cx="1280160" cy="50800"/>
-          </a:xfrm>
-          <a:prstGeom prst="rect">
-            <a:avLst/>
-          </a:prstGeom>
-          <a:solidFill>
-            <a:srgbClr val="304B35"/>
-          </a:solidFill>
-          <a:ln>
-            <a:noFill/>
-          </a:ln>
-          <a:effectLst/>
-        </p:spPr>
-        <p:style>
-          <a:lnRef idx="1">
-            <a:schemeClr val="accent1"/>
-          </a:lnRef>
-          <a:fillRef idx="3">
-            <a:schemeClr val="accent1"/>
-          </a:fillRef>
-          <a:effectRef idx="2">
-            <a:schemeClr val="accent1"/>
-          </a:effectRef>
-          <a:fontRef idx="minor">
-            <a:schemeClr val="lt1"/>
-          </a:fontRef>
-        </p:style>
-        <p:txBody>
-          <a:bodyPr rtlCol="0" anchor="ctr"/>
-          <a:lstStyle/>
-          <a:p>
-            <a:pPr algn="ctr"/>
-          </a:p>
-        </p:txBody>
-      </p:sp>
-      <p:sp>
-        <p:nvSpPr>
-          <p:cNvPr id="6" name="TextBox 5"/>
-          <p:cNvSpPr txBox="1"/>
-          <p:nvPr/>
-        </p:nvSpPr>
-        <p:spPr>
-          <a:xfrm>
-            <a:off x="640080" y="6446520"/>
-            <a:ext cx="10881360" cy="320040"/>
-          </a:xfrm>
-          <a:prstGeom prst="rect">
-            <a:avLst/>
-          </a:prstGeom>
-          <a:noFill/>
-        </p:spPr>
-        <p:txBody>
-          <a:bodyPr wrap="none">
-            <a:spAutoFit/>
-          </a:bodyPr>
-          <a:lstStyle/>
-          <a:p>
-            <a:r>
-              <a:rPr sz="1100">
-                <a:solidFill>
-                  <a:srgbClr val="6B7463"/>
-                </a:solidFill>
-                <a:latin typeface="Arial"/>
-              </a:rPr>
-              <a:t>Octro v2.2 — Track 1 Loaded</a:t>
-            </a:r>
-          </a:p>
-        </p:txBody>
-      </p:sp>
-      <p:sp>
-        <p:nvSpPr>
-          <p:cNvPr id="7" name="TextBox 6"/>
-          <p:cNvSpPr txBox="1"/>
-          <p:nvPr/>
-        </p:nvSpPr>
-        <p:spPr>
-          <a:xfrm>
-            <a:off x="685800" y="1920240"/>
-            <a:ext cx="10789920" cy="4389120"/>
-          </a:xfrm>
-          <a:prstGeom prst="rect">
-            <a:avLst/>
-          </a:prstGeom>
-          <a:noFill/>
-        </p:spPr>
-        <p:txBody>
-          <a:bodyPr wrap="square">
-            <a:spAutoFit/>
-          </a:bodyPr>
-          <a:lstStyle/>
-          <a:p>
-            <a:pPr>
-              <a:spcAft>
-                <a:spcPts val="1000"/>
-              </a:spcAft>
-            </a:pPr>
-            <a:r>
-              <a:rPr sz="2000" b="1">
+              <a:rPr sz="1350">
                 <a:solidFill>
                   <a:srgbClr val="20271F"/>
                 </a:solidFill>
@@ -5760,81 +4733,33 @@
           <a:p>
             <a:pPr>
               <a:spcAft>
-                <a:spcPts val="1000"/>
+                <a:spcPts val="600"/>
               </a:spcAft>
             </a:pPr>
             <a:r>
-              <a:rPr sz="2000" b="1">
+              <a:rPr sz="1350">
                 <a:solidFill>
                   <a:srgbClr val="20271F"/>
                 </a:solidFill>
                 <a:latin typeface="Arial"/>
               </a:rPr>
-              <a:t>▸ Scenario weights are declared and fixed (0.80 / 0.15 / 0.05), shown as assumptions</a:t>
+              <a:t>▸ Scenario weights are fixed (0.80 / 0.15 / 0.05), shown as assumptions</a:t>
             </a:r>
           </a:p>
           <a:p>
             <a:pPr>
               <a:spcAft>
-                <a:spcPts val="1000"/>
+                <a:spcPts val="600"/>
               </a:spcAft>
             </a:pPr>
             <a:r>
-              <a:rPr sz="2000" b="1">
+              <a:rPr sz="1350">
                 <a:solidFill>
                   <a:srgbClr val="20271F"/>
                 </a:solidFill>
                 <a:latin typeface="Arial"/>
               </a:rPr>
               <a:t>▸ The LLM explains an already-computed plan, it doesn't recompute it</a:t>
-            </a:r>
-          </a:p>
-          <a:p>
-            <a:pPr lvl="1">
-              <a:spcAft>
-                <a:spcPts val="400"/>
-              </a:spcAft>
-            </a:pPr>
-            <a:r>
-              <a:rPr sz="1600" b="0">
-                <a:solidFill>
-                  <a:srgbClr val="304B35"/>
-                </a:solidFill>
-                <a:latin typeface="Arial"/>
-              </a:rPr>
-              <a:t>–  Displayed figures come from the deterministic engine, never from generated text</a:t>
-            </a:r>
-          </a:p>
-          <a:p>
-            <a:pPr>
-              <a:spcAft>
-                <a:spcPts val="1000"/>
-              </a:spcAft>
-            </a:pPr>
-            <a:r>
-              <a:rPr sz="2000" b="1">
-                <a:solidFill>
-                  <a:srgbClr val="20271F"/>
-                </a:solidFill>
-                <a:latin typeface="Arial"/>
-              </a:rPr>
-              <a:t>▸ ML estimation of delays/defaults from history: out of scope for the MVP</a:t>
-            </a:r>
-          </a:p>
-          <a:p>
-            <a:pPr lvl="1">
-              <a:spcAft>
-                <a:spcPts val="400"/>
-              </a:spcAft>
-            </a:pPr>
-            <a:r>
-              <a:rPr sz="1600" b="0">
-                <a:solidFill>
-                  <a:srgbClr val="304B35"/>
-                </a:solidFill>
-                <a:latin typeface="Arial"/>
-              </a:rPr>
-              <a:t>–  Planned post-hackathon, with train/validation separation and calibration tests</a:t>
             </a:r>
           </a:p>
         </p:txBody>

</xml_diff>

<commit_message>
docs(presentation): add liquidity buffer and KYC credential gating
On the subject slide: the liquidity buffer wallet that advances
withdrawals when the shared vault is temporarily illiquid (capped at the
internal ledger balance), and that validated KYC issues a CredentialCreate
of type OCTRO_KYC_VALID required to interact with Octro's lending pools.

Co-Authored-By: Claude Sonnet 5 <noreply@anthropic.com>
Claude-Session: https://claude.ai/code/session_01GVjnCnga6LrWgo7YT1mivM
</commit_message>
<xml_diff>
--- a/docs/presentation/octro-presentation.pptx
+++ b/docs/presentation/octro-presentation.pptx
@@ -3475,7 +3475,7 @@
               </a:spcAft>
             </a:pPr>
             <a:r>
-              <a:rPr sz="2000" b="1">
+              <a:rPr sz="1800" b="1">
                 <a:solidFill>
                   <a:srgbClr val="20271F"/>
                 </a:solidFill>
@@ -3507,7 +3507,7 @@
               </a:spcAft>
             </a:pPr>
             <a:r>
-              <a:rPr sz="2000" b="1">
+              <a:rPr sz="1800" b="1">
                 <a:solidFill>
                   <a:srgbClr val="20271F"/>
                 </a:solidFill>
@@ -3539,7 +3539,7 @@
               </a:spcAft>
             </a:pPr>
             <a:r>
-              <a:rPr sz="2000" b="1">
+              <a:rPr sz="1800" b="1">
                 <a:solidFill>
                   <a:srgbClr val="20271F"/>
                 </a:solidFill>
@@ -3571,7 +3571,71 @@
               </a:spcAft>
             </a:pPr>
             <a:r>
-              <a:rPr sz="2000" b="1">
+              <a:rPr sz="1800" b="1">
+                <a:solidFill>
+                  <a:srgbClr val="20271F"/>
+                </a:solidFill>
+                <a:latin typeface="Arial"/>
+              </a:rPr>
+              <a:t>▸ A liquidity buffer wallet advances withdrawals when the shared vault is temporarily illiquid</a:t>
+            </a:r>
+          </a:p>
+          <a:p>
+            <a:pPr lvl="1">
+              <a:spcAft>
+                <a:spcPts val="400"/>
+              </a:spcAft>
+            </a:pPr>
+            <a:r>
+              <a:rPr sz="1600" b="0">
+                <a:solidFill>
+                  <a:srgbClr val="304B35"/>
+                </a:solidFill>
+                <a:latin typeface="Arial"/>
+              </a:rPr>
+              <a:t>–  Capped at the internal ledger balance; never a silent shortfall on a partial fill</a:t>
+            </a:r>
+          </a:p>
+          <a:p>
+            <a:pPr>
+              <a:spcAft>
+                <a:spcPts val="1000"/>
+              </a:spcAft>
+            </a:pPr>
+            <a:r>
+              <a:rPr sz="1800" b="1">
+                <a:solidFill>
+                  <a:srgbClr val="20271F"/>
+                </a:solidFill>
+                <a:latin typeface="Arial"/>
+              </a:rPr>
+              <a:t>▸ KYC validation issues a CredentialCreate of type OCTRO_KYC_VALID</a:t>
+            </a:r>
+          </a:p>
+          <a:p>
+            <a:pPr lvl="1">
+              <a:spcAft>
+                <a:spcPts val="400"/>
+              </a:spcAft>
+            </a:pPr>
+            <a:r>
+              <a:rPr sz="1600" b="0">
+                <a:solidFill>
+                  <a:srgbClr val="304B35"/>
+                </a:solidFill>
+                <a:latin typeface="Arial"/>
+              </a:rPr>
+              <a:t>–  Required to interact with Octro's lending pools; gates credit access without touching the forecasting baseline</a:t>
+            </a:r>
+          </a:p>
+          <a:p>
+            <a:pPr>
+              <a:spcAft>
+                <a:spcPts val="1000"/>
+              </a:spcAft>
+            </a:pPr>
+            <a:r>
+              <a:rPr sz="1800" b="1">
                 <a:solidFill>
                   <a:srgbClr val="20271F"/>
                 </a:solidFill>

</xml_diff>

<commit_message>
docs(presentation): clarify KYC eligibility is company-only for now
The Odoo-based credit eligibility check that gates lending-pool access
currently only supports companies; personal and independent forecasting
is unaffected by this and stays available to all three audiences, per
the codebase (ADR 0002, PER-11/ACC-01/ACC-02 invariants).

Co-Authored-By: Claude Sonnet 5 <noreply@anthropic.com>
Claude-Session: https://claude.ai/code/session_01GVjnCnga6LrWgo7YT1mivM
</commit_message>
<xml_diff>
--- a/docs/presentation/octro-presentation.pptx
+++ b/docs/presentation/octro-presentation.pptx
@@ -3609,7 +3609,7 @@
                 </a:solidFill>
                 <a:latin typeface="Arial"/>
               </a:rPr>
-              <a:t>▸ KYC validation issues a CredentialCreate of type OCTRO_KYC_VALID</a:t>
+              <a:t>▸ KYC validation (company-only for now, via Odoo-based eligibility) issues a CredentialCreate of type OCTRO_KYC_VALID</a:t>
             </a:r>
           </a:p>
           <a:p>
@@ -3625,7 +3625,7 @@
                 </a:solidFill>
                 <a:latin typeface="Arial"/>
               </a:rPr>
-              <a:t>–  Required to interact with Octro's lending pools; gates credit access without touching the forecasting baseline</a:t>
+              <a:t>–  Required to interact with Octro's lending pools; personal and independent forecasting stays unaffected</a:t>
             </a:r>
           </a:p>
           <a:p>

</xml_diff>

<commit_message>
docs(presentation): add slide numbers
Bottom-right "N / 6" on every slide, colored for contrast against each
slide's background.

Co-Authored-By: Claude Sonnet 5 <noreply@anthropic.com>
Claude-Session: https://claude.ai/code/session_01GVjnCnga6LrWgo7YT1mivM
</commit_message>
<xml_diff>
--- a/docs/presentation/octro-presentation.pptx
+++ b/docs/presentation/octro-presentation.pptx
@@ -3239,6 +3239,41 @@
           </a:p>
         </p:txBody>
       </p:sp>
+      <p:sp>
+        <p:nvSpPr>
+          <p:cNvPr id="6" name="TextBox 5"/>
+          <p:cNvSpPr txBox="1"/>
+          <p:nvPr/>
+        </p:nvSpPr>
+        <p:spPr>
+          <a:xfrm>
+            <a:off x="11292840" y="6446520"/>
+            <a:ext cx="640080" cy="320040"/>
+          </a:xfrm>
+          <a:prstGeom prst="rect">
+            <a:avLst/>
+          </a:prstGeom>
+          <a:noFill/>
+        </p:spPr>
+        <p:txBody>
+          <a:bodyPr wrap="none">
+            <a:spAutoFit/>
+          </a:bodyPr>
+          <a:lstStyle/>
+          <a:p>
+            <a:pPr algn="r"/>
+            <a:r>
+              <a:rPr sz="1100">
+                <a:solidFill>
+                  <a:srgbClr val="B8C98A"/>
+                </a:solidFill>
+                <a:latin typeface="Arial"/>
+              </a:rPr>
+              <a:t>1 / 6</a:t>
+            </a:r>
+          </a:p>
+        </p:txBody>
+      </p:sp>
     </p:spTree>
   </p:cSld>
   <p:clrMapOvr>
@@ -3646,6 +3681,41 @@
           </a:p>
         </p:txBody>
       </p:sp>
+      <p:sp>
+        <p:nvSpPr>
+          <p:cNvPr id="8" name="TextBox 7"/>
+          <p:cNvSpPr txBox="1"/>
+          <p:nvPr/>
+        </p:nvSpPr>
+        <p:spPr>
+          <a:xfrm>
+            <a:off x="11292840" y="6446520"/>
+            <a:ext cx="640080" cy="320040"/>
+          </a:xfrm>
+          <a:prstGeom prst="rect">
+            <a:avLst/>
+          </a:prstGeom>
+          <a:noFill/>
+        </p:spPr>
+        <p:txBody>
+          <a:bodyPr wrap="none">
+            <a:spAutoFit/>
+          </a:bodyPr>
+          <a:lstStyle/>
+          <a:p>
+            <a:pPr algn="r"/>
+            <a:r>
+              <a:rPr sz="1100">
+                <a:solidFill>
+                  <a:srgbClr val="6B7463"/>
+                </a:solidFill>
+                <a:latin typeface="Arial"/>
+              </a:rPr>
+              <a:t>2 / 6</a:t>
+            </a:r>
+          </a:p>
+        </p:txBody>
+      </p:sp>
     </p:spTree>
   </p:cSld>
   <p:clrMapOvr>
@@ -3743,6 +3813,41 @@
           </a:p>
         </p:txBody>
       </p:sp>
+      <p:sp>
+        <p:nvSpPr>
+          <p:cNvPr id="4" name="TextBox 3"/>
+          <p:cNvSpPr txBox="1"/>
+          <p:nvPr/>
+        </p:nvSpPr>
+        <p:spPr>
+          <a:xfrm>
+            <a:off x="11292840" y="6446520"/>
+            <a:ext cx="640080" cy="320040"/>
+          </a:xfrm>
+          <a:prstGeom prst="rect">
+            <a:avLst/>
+          </a:prstGeom>
+          <a:noFill/>
+        </p:spPr>
+        <p:txBody>
+          <a:bodyPr wrap="none">
+            <a:spAutoFit/>
+          </a:bodyPr>
+          <a:lstStyle/>
+          <a:p>
+            <a:pPr algn="r"/>
+            <a:r>
+              <a:rPr sz="1100">
+                <a:solidFill>
+                  <a:srgbClr val="B8C98A"/>
+                </a:solidFill>
+                <a:latin typeface="Arial"/>
+              </a:rPr>
+              <a:t>3 / 6</a:t>
+            </a:r>
+          </a:p>
+        </p:txBody>
+      </p:sp>
     </p:spTree>
   </p:cSld>
   <p:clrMapOvr>
@@ -4070,6 +4175,41 @@
           </a:p>
         </p:txBody>
       </p:sp>
+      <p:sp>
+        <p:nvSpPr>
+          <p:cNvPr id="8" name="TextBox 7"/>
+          <p:cNvSpPr txBox="1"/>
+          <p:nvPr/>
+        </p:nvSpPr>
+        <p:spPr>
+          <a:xfrm>
+            <a:off x="11292840" y="6446520"/>
+            <a:ext cx="640080" cy="320040"/>
+          </a:xfrm>
+          <a:prstGeom prst="rect">
+            <a:avLst/>
+          </a:prstGeom>
+          <a:noFill/>
+        </p:spPr>
+        <p:txBody>
+          <a:bodyPr wrap="none">
+            <a:spAutoFit/>
+          </a:bodyPr>
+          <a:lstStyle/>
+          <a:p>
+            <a:pPr algn="r"/>
+            <a:r>
+              <a:rPr sz="1100">
+                <a:solidFill>
+                  <a:srgbClr val="6B7463"/>
+                </a:solidFill>
+                <a:latin typeface="Arial"/>
+              </a:rPr>
+              <a:t>4 / 6</a:t>
+            </a:r>
+          </a:p>
+        </p:txBody>
+      </p:sp>
     </p:spTree>
   </p:cSld>
   <p:clrMapOvr>
@@ -4200,6 +4340,41 @@
           </a:p>
         </p:txBody>
       </p:sp>
+      <p:sp>
+        <p:nvSpPr>
+          <p:cNvPr id="5" name="TextBox 4"/>
+          <p:cNvSpPr txBox="1"/>
+          <p:nvPr/>
+        </p:nvSpPr>
+        <p:spPr>
+          <a:xfrm>
+            <a:off x="11292840" y="6446520"/>
+            <a:ext cx="640080" cy="320040"/>
+          </a:xfrm>
+          <a:prstGeom prst="rect">
+            <a:avLst/>
+          </a:prstGeom>
+          <a:noFill/>
+        </p:spPr>
+        <p:txBody>
+          <a:bodyPr wrap="none">
+            <a:spAutoFit/>
+          </a:bodyPr>
+          <a:lstStyle/>
+          <a:p>
+            <a:pPr algn="r"/>
+            <a:r>
+              <a:rPr sz="1100">
+                <a:solidFill>
+                  <a:srgbClr val="B8C98A"/>
+                </a:solidFill>
+                <a:latin typeface="Arial"/>
+              </a:rPr>
+              <a:t>5 / 6</a:t>
+            </a:r>
+          </a:p>
+        </p:txBody>
+      </p:sp>
     </p:spTree>
   </p:cSld>
   <p:clrMapOvr>
@@ -4824,6 +4999,41 @@
                 <a:latin typeface="Arial"/>
               </a:rPr>
               <a:t>▸ The LLM explains an already-computed plan, it doesn't recompute it</a:t>
+            </a:r>
+          </a:p>
+        </p:txBody>
+      </p:sp>
+      <p:sp>
+        <p:nvSpPr>
+          <p:cNvPr id="15" name="TextBox 14"/>
+          <p:cNvSpPr txBox="1"/>
+          <p:nvPr/>
+        </p:nvSpPr>
+        <p:spPr>
+          <a:xfrm>
+            <a:off x="11292840" y="6446520"/>
+            <a:ext cx="640080" cy="320040"/>
+          </a:xfrm>
+          <a:prstGeom prst="rect">
+            <a:avLst/>
+          </a:prstGeom>
+          <a:noFill/>
+        </p:spPr>
+        <p:txBody>
+          <a:bodyPr wrap="none">
+            <a:spAutoFit/>
+          </a:bodyPr>
+          <a:lstStyle/>
+          <a:p>
+            <a:pPr algn="r"/>
+            <a:r>
+              <a:rPr sz="1100">
+                <a:solidFill>
+                  <a:srgbClr val="6B7463"/>
+                </a:solidFill>
+                <a:latin typeface="Arial"/>
+              </a:rPr>
+              <a:t>6 / 6</a:t>
             </a:r>
           </a:p>
         </p:txBody>

</xml_diff>